<commit_message>
feat: upgrade PowerPoint presentation with Syne/Outfit fonts and photorealistic cleanroom studio imagery
</commit_message>
<xml_diff>
--- a/Smart_Component_Storage_Presentation.pptx
+++ b/Smart_Component_Storage_Presentation.pptx
@@ -3141,57 +3141,14 @@
       </p:sp>
       <p:sp>
         <p:nvSpPr>
-          <p:cNvPr id="3" name="Rectangle 2"/>
-          <p:cNvSpPr/>
-          <p:nvPr/>
-        </p:nvSpPr>
-        <p:spPr>
-          <a:xfrm>
-            <a:off x="731520" y="1645920"/>
-            <a:ext cx="182880" cy="3291840"/>
-          </a:xfrm>
-          <a:prstGeom prst="rect">
-            <a:avLst/>
-          </a:prstGeom>
-          <a:solidFill>
-            <a:srgbClr val="0284C7"/>
-          </a:solidFill>
-          <a:ln>
-            <a:noFill/>
-          </a:ln>
-        </p:spPr>
-        <p:style>
-          <a:lnRef idx="1">
-            <a:schemeClr val="accent1"/>
-          </a:lnRef>
-          <a:fillRef idx="3">
-            <a:schemeClr val="accent1"/>
-          </a:fillRef>
-          <a:effectRef idx="2">
-            <a:schemeClr val="accent1"/>
-          </a:effectRef>
-          <a:fontRef idx="minor">
-            <a:schemeClr val="lt1"/>
-          </a:fontRef>
-        </p:style>
-        <p:txBody>
-          <a:bodyPr rtlCol="0" anchor="ctr"/>
-          <a:lstStyle/>
-          <a:p>
-            <a:pPr algn="ctr"/>
-          </a:p>
-        </p:txBody>
-      </p:sp>
-      <p:sp>
-        <p:nvSpPr>
-          <p:cNvPr id="4" name="TextBox 3"/>
+          <p:cNvPr id="3" name="TextBox 2"/>
           <p:cNvSpPr txBox="1"/>
           <p:nvPr/>
         </p:nvSpPr>
         <p:spPr>
           <a:xfrm>
-            <a:off x="1097280" y="1463040"/>
-            <a:ext cx="9601200" cy="2011680"/>
+            <a:off x="731520" y="1097280"/>
+            <a:ext cx="5486400" cy="4754880"/>
           </a:xfrm>
           <a:prstGeom prst="rect">
             <a:avLst/>
@@ -3205,14 +3162,15 @@
           <a:lstStyle/>
           <a:p>
             <a:pPr>
-              <a:defRPr sz="4000" b="1">
-                <a:solidFill>
-                  <a:srgbClr val="0F172A"/>
-                </a:solidFill>
-              </a:defRPr>
-            </a:pPr>
-            <a:r>
-              <a:t>SMART COMPONENT STORAGE</a:t>
+              <a:defRPr sz="1000" b="1">
+                <a:solidFill>
+                  <a:srgbClr val="0284C7"/>
+                </a:solidFill>
+                <a:latin typeface="Space Mono"/>
+              </a:defRPr>
+            </a:pPr>
+            <a:r>
+              <a:t>NEXT-GENERATION SEMICONDUCTOR STORAGE</a:t>
             </a:r>
           </a:p>
           <a:p>
@@ -3220,14 +3178,51 @@
               <a:spcBef>
                 <a:spcPts val="800"/>
               </a:spcBef>
-              <a:defRPr sz="2000" b="1">
+              <a:defRPr sz="3600" b="1">
+                <a:solidFill>
+                  <a:srgbClr val="0F172A"/>
+                </a:solidFill>
+                <a:latin typeface="Syne"/>
+              </a:defRPr>
+            </a:pPr>
+            <a:r>
+              <a:t>SMART COMPONENT</a:t>
+            </a:r>
+            <a:br/>
+            <a:r>
+              <a:t>STORAGE</a:t>
+            </a:r>
+          </a:p>
+          <a:p>
+            <a:pPr>
+              <a:spcBef>
+                <a:spcPts val="1000"/>
+              </a:spcBef>
+              <a:defRPr sz="1500" b="1">
                 <a:solidFill>
                   <a:srgbClr val="0284C7"/>
                 </a:solidFill>
+                <a:latin typeface="Outfit"/>
               </a:defRPr>
             </a:pPr>
             <a:r>
               <a:t>Autonomous Cyber-Physical Telemetry &amp; Kinetic Arrhenius FEFO Management</a:t>
+            </a:r>
+          </a:p>
+          <a:p>
+            <a:pPr>
+              <a:spcBef>
+                <a:spcPts val="1200"/>
+              </a:spcBef>
+              <a:defRPr sz="1100">
+                <a:solidFill>
+                  <a:srgbClr val="475569"/>
+                </a:solidFill>
+                <a:latin typeface="Outfit"/>
+              </a:defRPr>
+            </a:pPr>
+            <a:r>
+              <a:t>An enterprise smart hardware enclosure with multimodal ESP32 sensing, real-time kinetic degradation physics, closed-loop micro-actuation, and a photorealistic 3D WebGL digital twin.</a:t>
             </a:r>
           </a:p>
           <a:p>
@@ -3235,28 +3230,29 @@
               <a:spcBef>
                 <a:spcPts val="1600"/>
               </a:spcBef>
-              <a:defRPr sz="1300">
-                <a:solidFill>
-                  <a:srgbClr val="475569"/>
-                </a:solidFill>
-              </a:defRPr>
-            </a:pPr>
-            <a:r>
-              <a:t>Hardware Integration · ESP32 Sensor Grid · Micro-Actuation · WebGL 3D Matrix · Production Ready</a:t>
-            </a:r>
-          </a:p>
-        </p:txBody>
-      </p:sp>
-      <p:sp>
-        <p:nvSpPr>
-          <p:cNvPr id="5" name="Rounded Rectangle 4"/>
+              <a:defRPr sz="950">
+                <a:solidFill>
+                  <a:srgbClr val="0F172A"/>
+                </a:solidFill>
+                <a:latin typeface="Space Mono"/>
+              </a:defRPr>
+            </a:pPr>
+            <a:r>
+              <a:t>• NEMA-4X Sealed   • Ea = 0.60 eV Arrhenius   • Vercel Edge Live</a:t>
+            </a:r>
+          </a:p>
+        </p:txBody>
+      </p:sp>
+      <p:sp>
+        <p:nvSpPr>
+          <p:cNvPr id="4" name="Rounded Rectangle 3"/>
           <p:cNvSpPr/>
           <p:nvPr/>
         </p:nvSpPr>
         <p:spPr>
           <a:xfrm>
-            <a:off x="1097280" y="4572000"/>
-            <a:ext cx="2377440" cy="1280160"/>
+            <a:off x="6400800" y="914400"/>
+            <a:ext cx="5029200" cy="5029200"/>
           </a:xfrm>
           <a:prstGeom prst="roundRect">
             <a:avLst/>
@@ -3292,341 +3288,30 @@
           </a:p>
         </p:txBody>
       </p:sp>
-      <p:sp>
-        <p:nvSpPr>
-          <p:cNvPr id="6" name="TextBox 5"/>
-          <p:cNvSpPr txBox="1"/>
-          <p:nvPr/>
-        </p:nvSpPr>
-        <p:spPr>
-          <a:xfrm>
-            <a:off x="1234440" y="4663440"/>
-            <a:ext cx="2103120" cy="1097280"/>
+      <p:pic>
+        <p:nvPicPr>
+          <p:cNvPr id="5" name="Picture 4" descr="smart_storage_hero_1791209876209.jpg"/>
+          <p:cNvPicPr>
+            <a:picLocks noChangeAspect="1"/>
+          </p:cNvPicPr>
+          <p:nvPr/>
+        </p:nvPicPr>
+        <p:blipFill>
+          <a:blip r:embed="rId2"/>
+          <a:stretch>
+            <a:fillRect/>
+          </a:stretch>
+        </p:blipFill>
+        <p:spPr>
+          <a:xfrm>
+            <a:off x="6492240" y="1005840"/>
+            <a:ext cx="4846320" cy="2704923"/>
           </a:xfrm>
           <a:prstGeom prst="rect">
             <a:avLst/>
           </a:prstGeom>
-          <a:noFill/>
-        </p:spPr>
-        <p:txBody>
-          <a:bodyPr wrap="none">
-            <a:spAutoFit/>
-          </a:bodyPr>
-          <a:lstStyle/>
-          <a:p>
-            <a:pPr>
-              <a:defRPr sz="1300" b="1">
-                <a:solidFill>
-                  <a:srgbClr val="0F172A"/>
-                </a:solidFill>
-              </a:defRPr>
-            </a:pPr>
-            <a:r>
-              <a:t>NEMA-4X Enclosure</a:t>
-            </a:r>
-          </a:p>
-          <a:p>
-            <a:pPr>
-              <a:spcBef>
-                <a:spcPts val="400"/>
-              </a:spcBef>
-              <a:defRPr sz="1000">
-                <a:solidFill>
-                  <a:srgbClr val="475569"/>
-                </a:solidFill>
-              </a:defRPr>
-            </a:pPr>
-            <a:r>
-              <a:t>Environmental Sealed</a:t>
-            </a:r>
-          </a:p>
-        </p:txBody>
-      </p:sp>
-      <p:sp>
-        <p:nvSpPr>
-          <p:cNvPr id="7" name="Rounded Rectangle 6"/>
-          <p:cNvSpPr/>
-          <p:nvPr/>
-        </p:nvSpPr>
-        <p:spPr>
-          <a:xfrm>
-            <a:off x="3657600" y="4572000"/>
-            <a:ext cx="2377440" cy="1280160"/>
-          </a:xfrm>
-          <a:prstGeom prst="roundRect">
-            <a:avLst/>
-          </a:prstGeom>
-          <a:solidFill>
-            <a:srgbClr val="FFFFFF"/>
-          </a:solidFill>
-          <a:ln w="12700">
-            <a:solidFill>
-              <a:srgbClr val="E2E8F0"/>
-            </a:solidFill>
-          </a:ln>
-        </p:spPr>
-        <p:style>
-          <a:lnRef idx="1">
-            <a:schemeClr val="accent1"/>
-          </a:lnRef>
-          <a:fillRef idx="3">
-            <a:schemeClr val="accent1"/>
-          </a:fillRef>
-          <a:effectRef idx="2">
-            <a:schemeClr val="accent1"/>
-          </a:effectRef>
-          <a:fontRef idx="minor">
-            <a:schemeClr val="lt1"/>
-          </a:fontRef>
-        </p:style>
-        <p:txBody>
-          <a:bodyPr rtlCol="0" anchor="ctr"/>
-          <a:lstStyle/>
-          <a:p>
-            <a:pPr algn="ctr"/>
-          </a:p>
-        </p:txBody>
-      </p:sp>
-      <p:sp>
-        <p:nvSpPr>
-          <p:cNvPr id="8" name="TextBox 7"/>
-          <p:cNvSpPr txBox="1"/>
-          <p:nvPr/>
-        </p:nvSpPr>
-        <p:spPr>
-          <a:xfrm>
-            <a:off x="3794760" y="4663440"/>
-            <a:ext cx="2103120" cy="1097280"/>
-          </a:xfrm>
-          <a:prstGeom prst="rect">
-            <a:avLst/>
-          </a:prstGeom>
-          <a:noFill/>
-        </p:spPr>
-        <p:txBody>
-          <a:bodyPr wrap="none">
-            <a:spAutoFit/>
-          </a:bodyPr>
-          <a:lstStyle/>
-          <a:p>
-            <a:pPr>
-              <a:defRPr sz="1300" b="1">
-                <a:solidFill>
-                  <a:srgbClr val="0F172A"/>
-                </a:solidFill>
-              </a:defRPr>
-            </a:pPr>
-            <a:r>
-              <a:t>Arrhenius Engine</a:t>
-            </a:r>
-          </a:p>
-          <a:p>
-            <a:pPr>
-              <a:spcBef>
-                <a:spcPts val="400"/>
-              </a:spcBef>
-              <a:defRPr sz="1000">
-                <a:solidFill>
-                  <a:srgbClr val="475569"/>
-                </a:solidFill>
-              </a:defRPr>
-            </a:pPr>
-            <a:r>
-              <a:t>Kinetic Shelf-Life</a:t>
-            </a:r>
-          </a:p>
-        </p:txBody>
-      </p:sp>
-      <p:sp>
-        <p:nvSpPr>
-          <p:cNvPr id="9" name="Rounded Rectangle 8"/>
-          <p:cNvSpPr/>
-          <p:nvPr/>
-        </p:nvSpPr>
-        <p:spPr>
-          <a:xfrm>
-            <a:off x="6217920" y="4572000"/>
-            <a:ext cx="2377440" cy="1280160"/>
-          </a:xfrm>
-          <a:prstGeom prst="roundRect">
-            <a:avLst/>
-          </a:prstGeom>
-          <a:solidFill>
-            <a:srgbClr val="FFFFFF"/>
-          </a:solidFill>
-          <a:ln w="12700">
-            <a:solidFill>
-              <a:srgbClr val="E2E8F0"/>
-            </a:solidFill>
-          </a:ln>
-        </p:spPr>
-        <p:style>
-          <a:lnRef idx="1">
-            <a:schemeClr val="accent1"/>
-          </a:lnRef>
-          <a:fillRef idx="3">
-            <a:schemeClr val="accent1"/>
-          </a:fillRef>
-          <a:effectRef idx="2">
-            <a:schemeClr val="accent1"/>
-          </a:effectRef>
-          <a:fontRef idx="minor">
-            <a:schemeClr val="lt1"/>
-          </a:fontRef>
-        </p:style>
-        <p:txBody>
-          <a:bodyPr rtlCol="0" anchor="ctr"/>
-          <a:lstStyle/>
-          <a:p>
-            <a:pPr algn="ctr"/>
-          </a:p>
-        </p:txBody>
-      </p:sp>
-      <p:sp>
-        <p:nvSpPr>
-          <p:cNvPr id="10" name="TextBox 9"/>
-          <p:cNvSpPr txBox="1"/>
-          <p:nvPr/>
-        </p:nvSpPr>
-        <p:spPr>
-          <a:xfrm>
-            <a:off x="6355080" y="4663440"/>
-            <a:ext cx="2103120" cy="1097280"/>
-          </a:xfrm>
-          <a:prstGeom prst="rect">
-            <a:avLst/>
-          </a:prstGeom>
-          <a:noFill/>
-        </p:spPr>
-        <p:txBody>
-          <a:bodyPr wrap="none">
-            <a:spAutoFit/>
-          </a:bodyPr>
-          <a:lstStyle/>
-          <a:p>
-            <a:pPr>
-              <a:defRPr sz="1300" b="1">
-                <a:solidFill>
-                  <a:srgbClr val="0F172A"/>
-                </a:solidFill>
-              </a:defRPr>
-            </a:pPr>
-            <a:r>
-              <a:t>Photorealistic 3D</a:t>
-            </a:r>
-          </a:p>
-          <a:p>
-            <a:pPr>
-              <a:spcBef>
-                <a:spcPts val="400"/>
-              </a:spcBef>
-              <a:defRPr sz="1000">
-                <a:solidFill>
-                  <a:srgbClr val="475569"/>
-                </a:solidFill>
-              </a:defRPr>
-            </a:pPr>
-            <a:r>
-              <a:t>Interactive Raycasting</a:t>
-            </a:r>
-          </a:p>
-        </p:txBody>
-      </p:sp>
-      <p:sp>
-        <p:nvSpPr>
-          <p:cNvPr id="11" name="Rounded Rectangle 10"/>
-          <p:cNvSpPr/>
-          <p:nvPr/>
-        </p:nvSpPr>
-        <p:spPr>
-          <a:xfrm>
-            <a:off x="8778239" y="4572000"/>
-            <a:ext cx="2377440" cy="1280160"/>
-          </a:xfrm>
-          <a:prstGeom prst="roundRect">
-            <a:avLst/>
-          </a:prstGeom>
-          <a:solidFill>
-            <a:srgbClr val="FFFFFF"/>
-          </a:solidFill>
-          <a:ln w="12700">
-            <a:solidFill>
-              <a:srgbClr val="E2E8F0"/>
-            </a:solidFill>
-          </a:ln>
-        </p:spPr>
-        <p:style>
-          <a:lnRef idx="1">
-            <a:schemeClr val="accent1"/>
-          </a:lnRef>
-          <a:fillRef idx="3">
-            <a:schemeClr val="accent1"/>
-          </a:fillRef>
-          <a:effectRef idx="2">
-            <a:schemeClr val="accent1"/>
-          </a:effectRef>
-          <a:fontRef idx="minor">
-            <a:schemeClr val="lt1"/>
-          </a:fontRef>
-        </p:style>
-        <p:txBody>
-          <a:bodyPr rtlCol="0" anchor="ctr"/>
-          <a:lstStyle/>
-          <a:p>
-            <a:pPr algn="ctr"/>
-          </a:p>
-        </p:txBody>
-      </p:sp>
-      <p:sp>
-        <p:nvSpPr>
-          <p:cNvPr id="12" name="TextBox 11"/>
-          <p:cNvSpPr txBox="1"/>
-          <p:nvPr/>
-        </p:nvSpPr>
-        <p:spPr>
-          <a:xfrm>
-            <a:off x="8915399" y="4663440"/>
-            <a:ext cx="2103120" cy="1097280"/>
-          </a:xfrm>
-          <a:prstGeom prst="rect">
-            <a:avLst/>
-          </a:prstGeom>
-          <a:noFill/>
-        </p:spPr>
-        <p:txBody>
-          <a:bodyPr wrap="none">
-            <a:spAutoFit/>
-          </a:bodyPr>
-          <a:lstStyle/>
-          <a:p>
-            <a:pPr>
-              <a:defRPr sz="1300" b="1">
-                <a:solidFill>
-                  <a:srgbClr val="0F172A"/>
-                </a:solidFill>
-              </a:defRPr>
-            </a:pPr>
-            <a:r>
-              <a:t>Sub-10ms Telemetry</a:t>
-            </a:r>
-          </a:p>
-          <a:p>
-            <a:pPr>
-              <a:spcBef>
-                <a:spcPts val="400"/>
-              </a:spcBef>
-              <a:defRPr sz="1000">
-                <a:solidFill>
-                  <a:srgbClr val="475569"/>
-                </a:solidFill>
-              </a:defRPr>
-            </a:pPr>
-            <a:r>
-              <a:t>WebSocket Bus</a:t>
-            </a:r>
-          </a:p>
-        </p:txBody>
-      </p:sp>
+        </p:spPr>
+      </p:pic>
     </p:spTree>
   </p:cSld>
   <p:clrMapOvr>
@@ -3697,7 +3382,7 @@
         <p:spPr>
           <a:xfrm>
             <a:off x="731520" y="365760"/>
-            <a:ext cx="10515600" cy="320040"/>
+            <a:ext cx="9144000" cy="320040"/>
           </a:xfrm>
           <a:prstGeom prst="rect">
             <a:avLst/>
@@ -3711,14 +3396,15 @@
           <a:lstStyle/>
           <a:p>
             <a:pPr>
-              <a:defRPr sz="1000" b="1">
+              <a:defRPr sz="950" b="1">
                 <a:solidFill>
                   <a:srgbClr val="0284C7"/>
                 </a:solidFill>
-              </a:defRPr>
-            </a:pPr>
-            <a:r>
-              <a:t>INDUSTRY CHALLENGES &amp; MOTIVATION</a:t>
+                <a:latin typeface="Space Mono"/>
+              </a:defRPr>
+            </a:pPr>
+            <a:r>
+              <a:t>MOTIVATION &amp; URGENCY</a:t>
             </a:r>
           </a:p>
         </p:txBody>
@@ -3731,8 +3417,8 @@
         </p:nvSpPr>
         <p:spPr>
           <a:xfrm>
-            <a:off x="731520" y="685800"/>
-            <a:ext cx="10515600" cy="594360"/>
+            <a:off x="731520" y="658368"/>
+            <a:ext cx="9601200" cy="594360"/>
           </a:xfrm>
           <a:prstGeom prst="rect">
             <a:avLst/>
@@ -3746,28 +3432,65 @@
           <a:lstStyle/>
           <a:p>
             <a:pPr>
-              <a:defRPr sz="2600" b="1">
+              <a:defRPr sz="2500" b="1">
                 <a:solidFill>
                   <a:srgbClr val="0F172A"/>
                 </a:solidFill>
-              </a:defRPr>
-            </a:pPr>
-            <a:r>
-              <a:t>Executive Overview: Solving Component Degradation</a:t>
-            </a:r>
-          </a:p>
-        </p:txBody>
-      </p:sp>
-      <p:sp>
-        <p:nvSpPr>
-          <p:cNvPr id="5" name="Rounded Rectangle 4"/>
+                <a:latin typeface="Syne"/>
+              </a:defRPr>
+            </a:pPr>
+            <a:r>
+              <a:t>The Critical Industry Challenge: Silent Excursions</a:t>
+            </a:r>
+          </a:p>
+        </p:txBody>
+      </p:sp>
+      <p:sp>
+        <p:nvSpPr>
+          <p:cNvPr id="5" name="TextBox 4"/>
+          <p:cNvSpPr txBox="1"/>
+          <p:nvPr/>
+        </p:nvSpPr>
+        <p:spPr>
+          <a:xfrm>
+            <a:off x="10515600" y="365760"/>
+            <a:ext cx="1097280" cy="365760"/>
+          </a:xfrm>
+          <a:prstGeom prst="rect">
+            <a:avLst/>
+          </a:prstGeom>
+          <a:noFill/>
+        </p:spPr>
+        <p:txBody>
+          <a:bodyPr wrap="none">
+            <a:spAutoFit/>
+          </a:bodyPr>
+          <a:lstStyle/>
+          <a:p>
+            <a:pPr>
+              <a:defRPr sz="1100">
+                <a:solidFill>
+                  <a:srgbClr val="475569"/>
+                </a:solidFill>
+                <a:latin typeface="Space Mono"/>
+              </a:defRPr>
+            </a:pPr>
+            <a:r>
+              <a:t>02 / 09</a:t>
+            </a:r>
+          </a:p>
+        </p:txBody>
+      </p:sp>
+      <p:sp>
+        <p:nvSpPr>
+          <p:cNvPr id="6" name="Rounded Rectangle 5"/>
           <p:cNvSpPr/>
           <p:nvPr/>
         </p:nvSpPr>
         <p:spPr>
           <a:xfrm>
-            <a:off x="731520" y="1463040"/>
-            <a:ext cx="3383280" cy="4663440"/>
+            <a:off x="731520" y="1371600"/>
+            <a:ext cx="5303520" cy="2377440"/>
           </a:xfrm>
           <a:prstGeom prst="roundRect">
             <a:avLst/>
@@ -3805,57 +3528,14 @@
       </p:sp>
       <p:sp>
         <p:nvSpPr>
-          <p:cNvPr id="6" name="Rectangle 5"/>
-          <p:cNvSpPr/>
-          <p:nvPr/>
-        </p:nvSpPr>
-        <p:spPr>
-          <a:xfrm>
-            <a:off x="960120" y="1691640"/>
-            <a:ext cx="2926080" cy="54864"/>
-          </a:xfrm>
-          <a:prstGeom prst="rect">
-            <a:avLst/>
-          </a:prstGeom>
-          <a:solidFill>
-            <a:srgbClr val="F59E0B"/>
-          </a:solidFill>
-          <a:ln>
-            <a:noFill/>
-          </a:ln>
-        </p:spPr>
-        <p:style>
-          <a:lnRef idx="1">
-            <a:schemeClr val="accent1"/>
-          </a:lnRef>
-          <a:fillRef idx="3">
-            <a:schemeClr val="accent1"/>
-          </a:fillRef>
-          <a:effectRef idx="2">
-            <a:schemeClr val="accent1"/>
-          </a:effectRef>
-          <a:fontRef idx="minor">
-            <a:schemeClr val="lt1"/>
-          </a:fontRef>
-        </p:style>
-        <p:txBody>
-          <a:bodyPr rtlCol="0" anchor="ctr"/>
-          <a:lstStyle/>
-          <a:p>
-            <a:pPr algn="ctr"/>
-          </a:p>
-        </p:txBody>
-      </p:sp>
-      <p:sp>
-        <p:nvSpPr>
           <p:cNvPr id="7" name="TextBox 6"/>
           <p:cNvSpPr txBox="1"/>
           <p:nvPr/>
         </p:nvSpPr>
         <p:spPr>
           <a:xfrm>
-            <a:off x="960120" y="1874519"/>
-            <a:ext cx="2926080" cy="4114800"/>
+            <a:off x="914400" y="1508760"/>
+            <a:ext cx="4937760" cy="2103120"/>
           </a:xfrm>
           <a:prstGeom prst="rect">
             <a:avLst/>
@@ -3869,59 +3549,39 @@
           <a:lstStyle/>
           <a:p>
             <a:pPr>
-              <a:defRPr sz="1500" b="1">
+              <a:defRPr sz="1400" b="1">
                 <a:solidFill>
                   <a:srgbClr val="0F172A"/>
                 </a:solidFill>
-              </a:defRPr>
-            </a:pPr>
-            <a:r>
-              <a:t>The Critical Industry Problem</a:t>
+                <a:latin typeface="Syne"/>
+              </a:defRPr>
+            </a:pPr>
+            <a:r>
+              <a:t>The Problem: Unmonitored Storage Excursions</a:t>
             </a:r>
           </a:p>
           <a:p>
             <a:pPr>
               <a:spcBef>
-                <a:spcPts val="1200"/>
+                <a:spcPts val="600"/>
               </a:spcBef>
-              <a:defRPr sz="1150">
+              <a:defRPr sz="1050">
                 <a:solidFill>
                   <a:srgbClr val="475569"/>
                 </a:solidFill>
-              </a:defRPr>
-            </a:pPr>
-            <a:r>
-              <a:t>•  Unmonitored environmental excursions (heat &amp; humidity) accelerate semiconductor oxidation and moisture sensitivity (MSL).</a:t>
-            </a:r>
-          </a:p>
-          <a:p>
-            <a:pPr>
-              <a:spcBef>
-                <a:spcPts val="1200"/>
-              </a:spcBef>
-              <a:defRPr sz="1150">
-                <a:solidFill>
-                  <a:srgbClr val="475569"/>
-                </a:solidFill>
-              </a:defRPr>
-            </a:pPr>
-            <a:r>
-              <a:t>•  Standard warehouse FIFO routing ignores thermal stress history, leading to unexpected field failure in sensitive ICs.</a:t>
-            </a:r>
-          </a:p>
-          <a:p>
-            <a:pPr>
-              <a:spcBef>
-                <a:spcPts val="1200"/>
-              </a:spcBef>
-              <a:defRPr sz="1150">
-                <a:solidFill>
-                  <a:srgbClr val="475569"/>
-                </a:solidFill>
-              </a:defRPr>
-            </a:pPr>
-            <a:r>
-              <a:t>•  Disconnected hardware silos prevent automated corrective intervention prior to irreversible degradation.</a:t>
+                <a:latin typeface="Outfit"/>
+              </a:defRPr>
+            </a:pPr>
+            <a:r>
+              <a:t>• Thermal &amp; humidity spikes accelerate MSL moisture absorption and pin oxidation.</a:t>
+            </a:r>
+            <a:br/>
+            <a:r>
+              <a:t>• Static FIFO calendars ignore cumulative stress, routing degraded reels to SMT lines.</a:t>
+            </a:r>
+            <a:br/>
+            <a:r>
+              <a:t>• Passive cabinets cause sudden PCB assembly failure and high warranty rework costs.</a:t>
             </a:r>
           </a:p>
         </p:txBody>
@@ -3934,8 +3594,8 @@
         </p:nvSpPr>
         <p:spPr>
           <a:xfrm>
-            <a:off x="4297680" y="1463040"/>
-            <a:ext cx="3383280" cy="4663440"/>
+            <a:off x="731520" y="3931920"/>
+            <a:ext cx="5303520" cy="2377440"/>
           </a:xfrm>
           <a:prstGeom prst="roundRect">
             <a:avLst/>
@@ -3973,57 +3633,14 @@
       </p:sp>
       <p:sp>
         <p:nvSpPr>
-          <p:cNvPr id="9" name="Rectangle 8"/>
-          <p:cNvSpPr/>
-          <p:nvPr/>
-        </p:nvSpPr>
-        <p:spPr>
-          <a:xfrm>
-            <a:off x="4526280" y="1691640"/>
-            <a:ext cx="2926080" cy="54864"/>
-          </a:xfrm>
-          <a:prstGeom prst="rect">
-            <a:avLst/>
-          </a:prstGeom>
-          <a:solidFill>
-            <a:srgbClr val="0284C7"/>
-          </a:solidFill>
-          <a:ln>
-            <a:noFill/>
-          </a:ln>
-        </p:spPr>
-        <p:style>
-          <a:lnRef idx="1">
-            <a:schemeClr val="accent1"/>
-          </a:lnRef>
-          <a:fillRef idx="3">
-            <a:schemeClr val="accent1"/>
-          </a:fillRef>
-          <a:effectRef idx="2">
-            <a:schemeClr val="accent1"/>
-          </a:effectRef>
-          <a:fontRef idx="minor">
-            <a:schemeClr val="lt1"/>
-          </a:fontRef>
-        </p:style>
-        <p:txBody>
-          <a:bodyPr rtlCol="0" anchor="ctr"/>
-          <a:lstStyle/>
-          <a:p>
-            <a:pPr algn="ctr"/>
-          </a:p>
-        </p:txBody>
-      </p:sp>
-      <p:sp>
-        <p:nvSpPr>
-          <p:cNvPr id="10" name="TextBox 9"/>
+          <p:cNvPr id="9" name="TextBox 8"/>
           <p:cNvSpPr txBox="1"/>
           <p:nvPr/>
         </p:nvSpPr>
         <p:spPr>
           <a:xfrm>
-            <a:off x="4526280" y="1874519"/>
-            <a:ext cx="2926080" cy="4114800"/>
+            <a:off x="914400" y="4069080"/>
+            <a:ext cx="4937760" cy="2103120"/>
           </a:xfrm>
           <a:prstGeom prst="rect">
             <a:avLst/>
@@ -4037,73 +3654,53 @@
           <a:lstStyle/>
           <a:p>
             <a:pPr>
-              <a:defRPr sz="1500" b="1">
-                <a:solidFill>
-                  <a:srgbClr val="0F172A"/>
-                </a:solidFill>
-              </a:defRPr>
-            </a:pPr>
-            <a:r>
-              <a:t>The Cyber-Physical Solution</a:t>
+              <a:defRPr sz="1400" b="1">
+                <a:solidFill>
+                  <a:srgbClr val="0284C7"/>
+                </a:solidFill>
+                <a:latin typeface="Syne"/>
+              </a:defRPr>
+            </a:pPr>
+            <a:r>
+              <a:t>The Solution: Continuous Cyber-Physical Regulation</a:t>
             </a:r>
           </a:p>
           <a:p>
             <a:pPr>
               <a:spcBef>
-                <a:spcPts val="1200"/>
+                <a:spcPts val="600"/>
               </a:spcBef>
-              <a:defRPr sz="1150">
+              <a:defRPr sz="1050">
                 <a:solidFill>
                   <a:srgbClr val="475569"/>
                 </a:solidFill>
-              </a:defRPr>
-            </a:pPr>
-            <a:r>
-              <a:t>•  Active sensor integration via ESP32 telemetry bus monitoring continuous temperature, humidity, and gas sensors.</a:t>
-            </a:r>
-          </a:p>
-          <a:p>
-            <a:pPr>
-              <a:spcBef>
-                <a:spcPts val="1200"/>
-              </a:spcBef>
-              <a:defRPr sz="1150">
-                <a:solidFill>
-                  <a:srgbClr val="475569"/>
-                </a:solidFill>
-              </a:defRPr>
-            </a:pPr>
-            <a:r>
-              <a:t>•  Physics-grounded Arrhenius degradation modeling dynamically calculating effective remaining shelf-life.</a:t>
-            </a:r>
-          </a:p>
-          <a:p>
-            <a:pPr>
-              <a:spcBef>
-                <a:spcPts val="1200"/>
-              </a:spcBef>
-              <a:defRPr sz="1150">
-                <a:solidFill>
-                  <a:srgbClr val="475569"/>
-                </a:solidFill>
-              </a:defRPr>
-            </a:pPr>
-            <a:r>
-              <a:t>•  Two-way closed-loop actuation automatically triggering Peltier cooling units and ventilation dampers upon drift.</a:t>
-            </a:r>
-          </a:p>
-        </p:txBody>
-      </p:sp>
-      <p:sp>
-        <p:nvSpPr>
-          <p:cNvPr id="11" name="Rounded Rectangle 10"/>
+                <a:latin typeface="Outfit"/>
+              </a:defRPr>
+            </a:pPr>
+            <a:r>
+              <a:t>• Active multimodal ESP32 telemetry bus with EMA sensor jitter smoothing.</a:t>
+            </a:r>
+            <a:br/>
+            <a:r>
+              <a:t>• Real-time Arrhenius kinetic engine dynamically calculating effective shelf-life.</a:t>
+            </a:r>
+            <a:br/>
+            <a:r>
+              <a:t>• Closed-loop Peltier thermoelectric refrigeration and motorized ventilation exhaust.</a:t>
+            </a:r>
+          </a:p>
+        </p:txBody>
+      </p:sp>
+      <p:sp>
+        <p:nvSpPr>
+          <p:cNvPr id="10" name="Rounded Rectangle 9"/>
           <p:cNvSpPr/>
           <p:nvPr/>
         </p:nvSpPr>
         <p:spPr>
           <a:xfrm>
-            <a:off x="7863840" y="1463040"/>
-            <a:ext cx="3383280" cy="4663440"/>
+            <a:off x="6309360" y="1371600"/>
+            <a:ext cx="5120640" cy="4937760"/>
           </a:xfrm>
           <a:prstGeom prst="roundRect">
             <a:avLst/>
@@ -4139,129 +3736,30 @@
           </a:p>
         </p:txBody>
       </p:sp>
-      <p:sp>
-        <p:nvSpPr>
-          <p:cNvPr id="12" name="Rectangle 11"/>
-          <p:cNvSpPr/>
-          <p:nvPr/>
-        </p:nvSpPr>
-        <p:spPr>
-          <a:xfrm>
-            <a:off x="8092440" y="1691640"/>
-            <a:ext cx="2926080" cy="54864"/>
+      <p:pic>
+        <p:nvPicPr>
+          <p:cNvPr id="11" name="Picture 10" descr="cleanroom_operator_picking_1791209936623.jpg"/>
+          <p:cNvPicPr>
+            <a:picLocks noChangeAspect="1"/>
+          </p:cNvPicPr>
+          <p:nvPr/>
+        </p:nvPicPr>
+        <p:blipFill>
+          <a:blip r:embed="rId2"/>
+          <a:stretch>
+            <a:fillRect/>
+          </a:stretch>
+        </p:blipFill>
+        <p:spPr>
+          <a:xfrm>
+            <a:off x="6400800" y="1463040"/>
+            <a:ext cx="4937760" cy="2755959"/>
           </a:xfrm>
           <a:prstGeom prst="rect">
             <a:avLst/>
           </a:prstGeom>
-          <a:solidFill>
-            <a:srgbClr val="10B981"/>
-          </a:solidFill>
-          <a:ln>
-            <a:noFill/>
-          </a:ln>
-        </p:spPr>
-        <p:style>
-          <a:lnRef idx="1">
-            <a:schemeClr val="accent1"/>
-          </a:lnRef>
-          <a:fillRef idx="3">
-            <a:schemeClr val="accent1"/>
-          </a:fillRef>
-          <a:effectRef idx="2">
-            <a:schemeClr val="accent1"/>
-          </a:effectRef>
-          <a:fontRef idx="minor">
-            <a:schemeClr val="lt1"/>
-          </a:fontRef>
-        </p:style>
-        <p:txBody>
-          <a:bodyPr rtlCol="0" anchor="ctr"/>
-          <a:lstStyle/>
-          <a:p>
-            <a:pPr algn="ctr"/>
-          </a:p>
-        </p:txBody>
-      </p:sp>
-      <p:sp>
-        <p:nvSpPr>
-          <p:cNvPr id="13" name="TextBox 12"/>
-          <p:cNvSpPr txBox="1"/>
-          <p:nvPr/>
-        </p:nvSpPr>
-        <p:spPr>
-          <a:xfrm>
-            <a:off x="8092440" y="1874519"/>
-            <a:ext cx="2926080" cy="4114800"/>
-          </a:xfrm>
-          <a:prstGeom prst="rect">
-            <a:avLst/>
-          </a:prstGeom>
-          <a:noFill/>
-        </p:spPr>
-        <p:txBody>
-          <a:bodyPr wrap="square">
-            <a:spAutoFit/>
-          </a:bodyPr>
-          <a:lstStyle/>
-          <a:p>
-            <a:pPr>
-              <a:defRPr sz="1500" b="1">
-                <a:solidFill>
-                  <a:srgbClr val="0F172A"/>
-                </a:solidFill>
-              </a:defRPr>
-            </a:pPr>
-            <a:r>
-              <a:t>Key Measured Outcomes</a:t>
-            </a:r>
-          </a:p>
-          <a:p>
-            <a:pPr>
-              <a:spcBef>
-                <a:spcPts val="1200"/>
-              </a:spcBef>
-              <a:defRPr sz="1150">
-                <a:solidFill>
-                  <a:srgbClr val="475569"/>
-                </a:solidFill>
-              </a:defRPr>
-            </a:pPr>
-            <a:r>
-              <a:t>•  Zero unmonitored thermal excursions across sensitive reels.</a:t>
-            </a:r>
-          </a:p>
-          <a:p>
-            <a:pPr>
-              <a:spcBef>
-                <a:spcPts val="1200"/>
-              </a:spcBef>
-              <a:defRPr sz="1150">
-                <a:solidFill>
-                  <a:srgbClr val="475569"/>
-                </a:solidFill>
-              </a:defRPr>
-            </a:pPr>
-            <a:r>
-              <a:t>•  4.2x faster emergency stock dispatch via stress-informed FEFO prioritization.</a:t>
-            </a:r>
-          </a:p>
-          <a:p>
-            <a:pPr>
-              <a:spcBef>
-                <a:spcPts val="1200"/>
-              </a:spcBef>
-              <a:defRPr sz="1150">
-                <a:solidFill>
-                  <a:srgbClr val="475569"/>
-                </a:solidFill>
-              </a:defRPr>
-            </a:pPr>
-            <a:r>
-              <a:t>•  Full traceability with ESP32 cryptographic HMAC authentication and real-time 3D bay location beacons.</a:t>
-            </a:r>
-          </a:p>
-        </p:txBody>
-      </p:sp>
+        </p:spPr>
+      </p:pic>
     </p:spTree>
   </p:cSld>
   <p:clrMapOvr>
@@ -4332,7 +3830,7 @@
         <p:spPr>
           <a:xfrm>
             <a:off x="731520" y="365760"/>
-            <a:ext cx="10515600" cy="320040"/>
+            <a:ext cx="9144000" cy="320040"/>
           </a:xfrm>
           <a:prstGeom prst="rect">
             <a:avLst/>
@@ -4346,14 +3844,15 @@
           <a:lstStyle/>
           <a:p>
             <a:pPr>
-              <a:defRPr sz="1000" b="1">
+              <a:defRPr sz="950" b="1">
                 <a:solidFill>
                   <a:srgbClr val="0284C7"/>
                 </a:solidFill>
-              </a:defRPr>
-            </a:pPr>
-            <a:r>
-              <a:t>FULL STACK TOPOLOGY</a:t>
+                <a:latin typeface="Space Mono"/>
+              </a:defRPr>
+            </a:pPr>
+            <a:r>
+              <a:t>FULL STACK ARCHITECTURE</a:t>
             </a:r>
           </a:p>
         </p:txBody>
@@ -4366,8 +3865,8 @@
         </p:nvSpPr>
         <p:spPr>
           <a:xfrm>
-            <a:off x="731520" y="685800"/>
-            <a:ext cx="10515600" cy="594360"/>
+            <a:off x="731520" y="658368"/>
+            <a:ext cx="9601200" cy="594360"/>
           </a:xfrm>
           <a:prstGeom prst="rect">
             <a:avLst/>
@@ -4381,28 +3880,65 @@
           <a:lstStyle/>
           <a:p>
             <a:pPr>
-              <a:defRPr sz="2600" b="1">
+              <a:defRPr sz="2500" b="1">
                 <a:solidFill>
                   <a:srgbClr val="0F172A"/>
                 </a:solidFill>
-              </a:defRPr>
-            </a:pPr>
-            <a:r>
-              <a:t>System Architecture: End-to-End Cyber-Physical Grid</a:t>
-            </a:r>
-          </a:p>
-        </p:txBody>
-      </p:sp>
-      <p:sp>
-        <p:nvSpPr>
-          <p:cNvPr id="5" name="Rounded Rectangle 4"/>
+                <a:latin typeface="Syne"/>
+              </a:defRPr>
+            </a:pPr>
+            <a:r>
+              <a:t>System Topology: End-to-End Hardware &amp; Edge Pipeline</a:t>
+            </a:r>
+          </a:p>
+        </p:txBody>
+      </p:sp>
+      <p:sp>
+        <p:nvSpPr>
+          <p:cNvPr id="5" name="TextBox 4"/>
+          <p:cNvSpPr txBox="1"/>
+          <p:nvPr/>
+        </p:nvSpPr>
+        <p:spPr>
+          <a:xfrm>
+            <a:off x="10515600" y="365760"/>
+            <a:ext cx="1097280" cy="365760"/>
+          </a:xfrm>
+          <a:prstGeom prst="rect">
+            <a:avLst/>
+          </a:prstGeom>
+          <a:noFill/>
+        </p:spPr>
+        <p:txBody>
+          <a:bodyPr wrap="none">
+            <a:spAutoFit/>
+          </a:bodyPr>
+          <a:lstStyle/>
+          <a:p>
+            <a:pPr>
+              <a:defRPr sz="1100">
+                <a:solidFill>
+                  <a:srgbClr val="475569"/>
+                </a:solidFill>
+                <a:latin typeface="Space Mono"/>
+              </a:defRPr>
+            </a:pPr>
+            <a:r>
+              <a:t>03 / 09</a:t>
+            </a:r>
+          </a:p>
+        </p:txBody>
+      </p:sp>
+      <p:sp>
+        <p:nvSpPr>
+          <p:cNvPr id="6" name="Rounded Rectangle 5"/>
           <p:cNvSpPr/>
           <p:nvPr/>
         </p:nvSpPr>
         <p:spPr>
           <a:xfrm>
-            <a:off x="731520" y="1463040"/>
-            <a:ext cx="2560320" cy="4663440"/>
+            <a:off x="731520" y="1371600"/>
+            <a:ext cx="5669280" cy="4937760"/>
           </a:xfrm>
           <a:prstGeom prst="roundRect">
             <a:avLst/>
@@ -4440,14 +3976,14 @@
       </p:sp>
       <p:sp>
         <p:nvSpPr>
-          <p:cNvPr id="6" name="TextBox 5"/>
+          <p:cNvPr id="7" name="TextBox 6"/>
           <p:cNvSpPr txBox="1"/>
           <p:nvPr/>
         </p:nvSpPr>
         <p:spPr>
           <a:xfrm>
-            <a:off x="914400" y="1645920"/>
-            <a:ext cx="2194560" cy="4297680"/>
+            <a:off x="914400" y="1554480"/>
+            <a:ext cx="5303520" cy="4572000"/>
           </a:xfrm>
           <a:prstGeom prst="rect">
             <a:avLst/>
@@ -4461,118 +3997,141 @@
           <a:lstStyle/>
           <a:p>
             <a:pPr>
-              <a:defRPr sz="1400" b="1">
-                <a:solidFill>
-                  <a:srgbClr val="0F172A"/>
-                </a:solidFill>
-              </a:defRPr>
-            </a:pPr>
-            <a:r>
-              <a:t>1. Physical Enclosure</a:t>
+              <a:defRPr sz="1300" b="1">
+                <a:solidFill>
+                  <a:srgbClr val="0284C7"/>
+                </a:solidFill>
+                <a:latin typeface="Syne"/>
+              </a:defRPr>
+            </a:pPr>
+            <a:r>
+              <a:t>1. Tier 1: Hardware Core</a:t>
             </a:r>
           </a:p>
           <a:p>
             <a:pPr>
               <a:spcBef>
-                <a:spcPts val="300"/>
+                <a:spcPts val="200"/>
               </a:spcBef>
-              <a:defRPr sz="950" b="1">
+              <a:defRPr sz="1050">
+                <a:solidFill>
+                  <a:srgbClr val="475569"/>
+                </a:solidFill>
+                <a:latin typeface="Outfit"/>
+              </a:defRPr>
+            </a:pPr>
+            <a:r>
+              <a:t>ESP32 dual-core, SHT31, DHT22, TEC1-12706 Peltier, MG996R servo, LED bay beacons.</a:t>
+            </a:r>
+          </a:p>
+          <a:p>
+            <a:pPr>
+              <a:spcBef>
+                <a:spcPts val="1000"/>
+              </a:spcBef>
+              <a:defRPr sz="1300" b="1">
                 <a:solidFill>
                   <a:srgbClr val="0284C7"/>
                 </a:solidFill>
-              </a:defRPr>
-            </a:pPr>
-            <a:r>
-              <a:t>HARDWARE LAYER</a:t>
+                <a:latin typeface="Syne"/>
+              </a:defRPr>
+            </a:pPr>
+            <a:r>
+              <a:t>2. Tier 2: Transport &amp; Security</a:t>
             </a:r>
           </a:p>
           <a:p>
             <a:pPr>
               <a:spcBef>
-                <a:spcPts val="900"/>
+                <a:spcPts val="200"/>
               </a:spcBef>
-              <a:defRPr sz="1100">
+              <a:defRPr sz="1050">
                 <a:solidFill>
                   <a:srgbClr val="475569"/>
                 </a:solidFill>
-              </a:defRPr>
-            </a:pPr>
-            <a:r>
-              <a:t>✓ ESP32-WROOM-32D Core</a:t>
+                <a:latin typeface="Outfit"/>
+              </a:defRPr>
+            </a:pPr>
+            <a:r>
+              <a:t>ESP32 HMAC-SHA256 signature verification, anti-replay nonce buffer, sub-10ms WebSockets.</a:t>
             </a:r>
           </a:p>
           <a:p>
             <a:pPr>
               <a:spcBef>
-                <a:spcPts val="900"/>
+                <a:spcPts val="1000"/>
               </a:spcBef>
-              <a:defRPr sz="1100">
+              <a:defRPr sz="1300" b="1">
+                <a:solidFill>
+                  <a:srgbClr val="0284C7"/>
+                </a:solidFill>
+                <a:latin typeface="Syne"/>
+              </a:defRPr>
+            </a:pPr>
+            <a:r>
+              <a:t>3. Tier 3: Analytical Physics Core</a:t>
+            </a:r>
+          </a:p>
+          <a:p>
+            <a:pPr>
+              <a:spcBef>
+                <a:spcPts val="200"/>
+              </a:spcBef>
+              <a:defRPr sz="1050">
                 <a:solidFill>
                   <a:srgbClr val="475569"/>
                 </a:solidFill>
-              </a:defRPr>
-            </a:pPr>
-            <a:r>
-              <a:t>✓ Sensors: SHT31, DHT22, BME680</a:t>
+                <a:latin typeface="Outfit"/>
+              </a:defRPr>
+            </a:pPr>
+            <a:r>
+              <a:t>Arrhenius degradation modeling (Ea = 0.60 eV), acceleration factor rating, FEFO ledger.</a:t>
             </a:r>
           </a:p>
           <a:p>
             <a:pPr>
               <a:spcBef>
-                <a:spcPts val="900"/>
+                <a:spcPts val="1000"/>
               </a:spcBef>
-              <a:defRPr sz="1100">
+              <a:defRPr sz="1300" b="1">
+                <a:solidFill>
+                  <a:srgbClr val="0284C7"/>
+                </a:solidFill>
+                <a:latin typeface="Syne"/>
+              </a:defRPr>
+            </a:pPr>
+            <a:r>
+              <a:t>4. Tier 4: Cleanroom Portal</a:t>
+            </a:r>
+          </a:p>
+          <a:p>
+            <a:pPr>
+              <a:spcBef>
+                <a:spcPts val="200"/>
+              </a:spcBef>
+              <a:defRPr sz="1050">
                 <a:solidFill>
                   <a:srgbClr val="475569"/>
                 </a:solidFill>
-              </a:defRPr>
-            </a:pPr>
-            <a:r>
-              <a:t>✓ Actuators: Peltier TEC1-12706</a:t>
-            </a:r>
-          </a:p>
-          <a:p>
-            <a:pPr>
-              <a:spcBef>
-                <a:spcPts val="900"/>
-              </a:spcBef>
-              <a:defRPr sz="1100">
-                <a:solidFill>
-                  <a:srgbClr val="475569"/>
-                </a:solidFill>
-              </a:defRPr>
-            </a:pPr>
-            <a:r>
-              <a:t>✓ Exhaust: MG996R Servos (90°)</a:t>
-            </a:r>
-          </a:p>
-          <a:p>
-            <a:pPr>
-              <a:spcBef>
-                <a:spcPts val="900"/>
-              </a:spcBef>
-              <a:defRPr sz="1100">
-                <a:solidFill>
-                  <a:srgbClr val="475569"/>
-                </a:solidFill>
-              </a:defRPr>
-            </a:pPr>
-            <a:r>
-              <a:t>✓ RGB Bay LED Pick Beacons</a:t>
-            </a:r>
-          </a:p>
-        </p:txBody>
-      </p:sp>
-      <p:sp>
-        <p:nvSpPr>
-          <p:cNvPr id="7" name="Rounded Rectangle 6"/>
+                <a:latin typeface="Outfit"/>
+              </a:defRPr>
+            </a:pPr>
+            <a:r>
+              <a:t>Next.js 16, Three.js 3D digital twin, 60 FPS CRT oscilloscope, live HUD dials.</a:t>
+            </a:r>
+          </a:p>
+        </p:txBody>
+      </p:sp>
+      <p:sp>
+        <p:nvSpPr>
+          <p:cNvPr id="8" name="Rounded Rectangle 7"/>
           <p:cNvSpPr/>
           <p:nvPr/>
         </p:nvSpPr>
         <p:spPr>
           <a:xfrm>
-            <a:off x="3429000" y="1463040"/>
-            <a:ext cx="2560320" cy="4663440"/>
+            <a:off x="6583680" y="1371600"/>
+            <a:ext cx="4846320" cy="4937760"/>
           </a:xfrm>
           <a:prstGeom prst="roundRect">
             <a:avLst/>
@@ -4608,471 +4167,30 @@
           </a:p>
         </p:txBody>
       </p:sp>
-      <p:sp>
-        <p:nvSpPr>
-          <p:cNvPr id="8" name="TextBox 7"/>
-          <p:cNvSpPr txBox="1"/>
-          <p:nvPr/>
-        </p:nvSpPr>
-        <p:spPr>
-          <a:xfrm>
-            <a:off x="3611880" y="1645920"/>
-            <a:ext cx="2194560" cy="4297680"/>
+      <p:pic>
+        <p:nvPicPr>
+          <p:cNvPr id="9" name="Picture 8" descr="esp32_iot_motherboard_1791209971559.jpg"/>
+          <p:cNvPicPr>
+            <a:picLocks noChangeAspect="1"/>
+          </p:cNvPicPr>
+          <p:nvPr/>
+        </p:nvPicPr>
+        <p:blipFill>
+          <a:blip r:embed="rId2"/>
+          <a:stretch>
+            <a:fillRect/>
+          </a:stretch>
+        </p:blipFill>
+        <p:spPr>
+          <a:xfrm>
+            <a:off x="6675120" y="1463040"/>
+            <a:ext cx="4663440" cy="2602850"/>
           </a:xfrm>
           <a:prstGeom prst="rect">
             <a:avLst/>
           </a:prstGeom>
-          <a:noFill/>
-        </p:spPr>
-        <p:txBody>
-          <a:bodyPr wrap="square">
-            <a:spAutoFit/>
-          </a:bodyPr>
-          <a:lstStyle/>
-          <a:p>
-            <a:pPr>
-              <a:defRPr sz="1400" b="1">
-                <a:solidFill>
-                  <a:srgbClr val="0F172A"/>
-                </a:solidFill>
-              </a:defRPr>
-            </a:pPr>
-            <a:r>
-              <a:t>2. Edge Security &amp; Ingestion</a:t>
-            </a:r>
-          </a:p>
-          <a:p>
-            <a:pPr>
-              <a:spcBef>
-                <a:spcPts val="300"/>
-              </a:spcBef>
-              <a:defRPr sz="950" b="1">
-                <a:solidFill>
-                  <a:srgbClr val="0284C7"/>
-                </a:solidFill>
-              </a:defRPr>
-            </a:pPr>
-            <a:r>
-              <a:t>TRANSPORT LAYER</a:t>
-            </a:r>
-          </a:p>
-          <a:p>
-            <a:pPr>
-              <a:spcBef>
-                <a:spcPts val="900"/>
-              </a:spcBef>
-              <a:defRPr sz="1100">
-                <a:solidFill>
-                  <a:srgbClr val="475569"/>
-                </a:solidFill>
-              </a:defRPr>
-            </a:pPr>
-            <a:r>
-              <a:t>✓ ESP32 HMAC-SHA256 Auth</a:t>
-            </a:r>
-          </a:p>
-          <a:p>
-            <a:pPr>
-              <a:spcBef>
-                <a:spcPts val="900"/>
-              </a:spcBef>
-              <a:defRPr sz="1100">
-                <a:solidFill>
-                  <a:srgbClr val="475569"/>
-                </a:solidFill>
-              </a:defRPr>
-            </a:pPr>
-            <a:r>
-              <a:t>✓ Anti-Replay Timestamp Window</a:t>
-            </a:r>
-          </a:p>
-          <a:p>
-            <a:pPr>
-              <a:spcBef>
-                <a:spcPts val="900"/>
-              </a:spcBef>
-              <a:defRPr sz="1100">
-                <a:solidFill>
-                  <a:srgbClr val="475569"/>
-                </a:solidFill>
-              </a:defRPr>
-            </a:pPr>
-            <a:r>
-              <a:t>✓ Exponential Moving Average (EMA)</a:t>
-            </a:r>
-          </a:p>
-          <a:p>
-            <a:pPr>
-              <a:spcBef>
-                <a:spcPts val="900"/>
-              </a:spcBef>
-              <a:defRPr sz="1100">
-                <a:solidFill>
-                  <a:srgbClr val="475569"/>
-                </a:solidFill>
-              </a:defRPr>
-            </a:pPr>
-            <a:r>
-              <a:t>✓ WebSocket Low-Latency Gateway</a:t>
-            </a:r>
-          </a:p>
-          <a:p>
-            <a:pPr>
-              <a:spcBef>
-                <a:spcPts val="900"/>
-              </a:spcBef>
-              <a:defRPr sz="1100">
-                <a:solidFill>
-                  <a:srgbClr val="475569"/>
-                </a:solidFill>
-              </a:defRPr>
-            </a:pPr>
-            <a:r>
-              <a:t>✓ FastAPI Asynchronous Daemon</a:t>
-            </a:r>
-          </a:p>
-        </p:txBody>
-      </p:sp>
-      <p:sp>
-        <p:nvSpPr>
-          <p:cNvPr id="9" name="Rounded Rectangle 8"/>
-          <p:cNvSpPr/>
-          <p:nvPr/>
-        </p:nvSpPr>
-        <p:spPr>
-          <a:xfrm>
-            <a:off x="6126480" y="1463040"/>
-            <a:ext cx="2560320" cy="4663440"/>
-          </a:xfrm>
-          <a:prstGeom prst="roundRect">
-            <a:avLst/>
-          </a:prstGeom>
-          <a:solidFill>
-            <a:srgbClr val="FFFFFF"/>
-          </a:solidFill>
-          <a:ln w="12700">
-            <a:solidFill>
-              <a:srgbClr val="E2E8F0"/>
-            </a:solidFill>
-          </a:ln>
-        </p:spPr>
-        <p:style>
-          <a:lnRef idx="1">
-            <a:schemeClr val="accent1"/>
-          </a:lnRef>
-          <a:fillRef idx="3">
-            <a:schemeClr val="accent1"/>
-          </a:fillRef>
-          <a:effectRef idx="2">
-            <a:schemeClr val="accent1"/>
-          </a:effectRef>
-          <a:fontRef idx="minor">
-            <a:schemeClr val="lt1"/>
-          </a:fontRef>
-        </p:style>
-        <p:txBody>
-          <a:bodyPr rtlCol="0" anchor="ctr"/>
-          <a:lstStyle/>
-          <a:p>
-            <a:pPr algn="ctr"/>
-          </a:p>
-        </p:txBody>
-      </p:sp>
-      <p:sp>
-        <p:nvSpPr>
-          <p:cNvPr id="10" name="TextBox 9"/>
-          <p:cNvSpPr txBox="1"/>
-          <p:nvPr/>
-        </p:nvSpPr>
-        <p:spPr>
-          <a:xfrm>
-            <a:off x="6309360" y="1645920"/>
-            <a:ext cx="2194560" cy="4297680"/>
-          </a:xfrm>
-          <a:prstGeom prst="rect">
-            <a:avLst/>
-          </a:prstGeom>
-          <a:noFill/>
-        </p:spPr>
-        <p:txBody>
-          <a:bodyPr wrap="square">
-            <a:spAutoFit/>
-          </a:bodyPr>
-          <a:lstStyle/>
-          <a:p>
-            <a:pPr>
-              <a:defRPr sz="1400" b="1">
-                <a:solidFill>
-                  <a:srgbClr val="0F172A"/>
-                </a:solidFill>
-              </a:defRPr>
-            </a:pPr>
-            <a:r>
-              <a:t>3. Physics Engine</a:t>
-            </a:r>
-          </a:p>
-          <a:p>
-            <a:pPr>
-              <a:spcBef>
-                <a:spcPts val="300"/>
-              </a:spcBef>
-              <a:defRPr sz="950" b="1">
-                <a:solidFill>
-                  <a:srgbClr val="0284C7"/>
-                </a:solidFill>
-              </a:defRPr>
-            </a:pPr>
-            <a:r>
-              <a:t>ANALYTICAL CORE</a:t>
-            </a:r>
-          </a:p>
-          <a:p>
-            <a:pPr>
-              <a:spcBef>
-                <a:spcPts val="900"/>
-              </a:spcBef>
-              <a:defRPr sz="1100">
-                <a:solidFill>
-                  <a:srgbClr val="475569"/>
-                </a:solidFill>
-              </a:defRPr>
-            </a:pPr>
-            <a:r>
-              <a:t>✓ Arrhenius Kinetic Degradation</a:t>
-            </a:r>
-          </a:p>
-          <a:p>
-            <a:pPr>
-              <a:spcBef>
-                <a:spcPts val="900"/>
-              </a:spcBef>
-              <a:defRPr sz="1100">
-                <a:solidFill>
-                  <a:srgbClr val="475569"/>
-                </a:solidFill>
-              </a:defRPr>
-            </a:pPr>
-            <a:r>
-              <a:t>✓ Activation Energy Ea = 0.60 eV</a:t>
-            </a:r>
-          </a:p>
-          <a:p>
-            <a:pPr>
-              <a:spcBef>
-                <a:spcPts val="900"/>
-              </a:spcBef>
-              <a:defRPr sz="1100">
-                <a:solidFill>
-                  <a:srgbClr val="475569"/>
-                </a:solidFill>
-              </a:defRPr>
-            </a:pPr>
-            <a:r>
-              <a:t>✓ Stress Acceleration Factor (AF)</a:t>
-            </a:r>
-          </a:p>
-          <a:p>
-            <a:pPr>
-              <a:spcBef>
-                <a:spcPts val="900"/>
-              </a:spcBef>
-              <a:defRPr sz="1100">
-                <a:solidFill>
-                  <a:srgbClr val="475569"/>
-                </a:solidFill>
-              </a:defRPr>
-            </a:pPr>
-            <a:r>
-              <a:t>✓ First-Expired First-Out (FEFO)</a:t>
-            </a:r>
-          </a:p>
-          <a:p>
-            <a:pPr>
-              <a:spcBef>
-                <a:spcPts val="900"/>
-              </a:spcBef>
-              <a:defRPr sz="1100">
-                <a:solidFill>
-                  <a:srgbClr val="475569"/>
-                </a:solidFill>
-              </a:defRPr>
-            </a:pPr>
-            <a:r>
-              <a:t>✓ Continuous Telemetry DB</a:t>
-            </a:r>
-          </a:p>
-        </p:txBody>
-      </p:sp>
-      <p:sp>
-        <p:nvSpPr>
-          <p:cNvPr id="11" name="Rounded Rectangle 10"/>
-          <p:cNvSpPr/>
-          <p:nvPr/>
-        </p:nvSpPr>
-        <p:spPr>
-          <a:xfrm>
-            <a:off x="8823960" y="1463040"/>
-            <a:ext cx="2560320" cy="4663440"/>
-          </a:xfrm>
-          <a:prstGeom prst="roundRect">
-            <a:avLst/>
-          </a:prstGeom>
-          <a:solidFill>
-            <a:srgbClr val="FFFFFF"/>
-          </a:solidFill>
-          <a:ln w="12700">
-            <a:solidFill>
-              <a:srgbClr val="E2E8F0"/>
-            </a:solidFill>
-          </a:ln>
-        </p:spPr>
-        <p:style>
-          <a:lnRef idx="1">
-            <a:schemeClr val="accent1"/>
-          </a:lnRef>
-          <a:fillRef idx="3">
-            <a:schemeClr val="accent1"/>
-          </a:fillRef>
-          <a:effectRef idx="2">
-            <a:schemeClr val="accent1"/>
-          </a:effectRef>
-          <a:fontRef idx="minor">
-            <a:schemeClr val="lt1"/>
-          </a:fontRef>
-        </p:style>
-        <p:txBody>
-          <a:bodyPr rtlCol="0" anchor="ctr"/>
-          <a:lstStyle/>
-          <a:p>
-            <a:pPr algn="ctr"/>
-          </a:p>
-        </p:txBody>
-      </p:sp>
-      <p:sp>
-        <p:nvSpPr>
-          <p:cNvPr id="12" name="TextBox 11"/>
-          <p:cNvSpPr txBox="1"/>
-          <p:nvPr/>
-        </p:nvSpPr>
-        <p:spPr>
-          <a:xfrm>
-            <a:off x="9006840" y="1645920"/>
-            <a:ext cx="2194560" cy="4297680"/>
-          </a:xfrm>
-          <a:prstGeom prst="rect">
-            <a:avLst/>
-          </a:prstGeom>
-          <a:noFill/>
-        </p:spPr>
-        <p:txBody>
-          <a:bodyPr wrap="square">
-            <a:spAutoFit/>
-          </a:bodyPr>
-          <a:lstStyle/>
-          <a:p>
-            <a:pPr>
-              <a:defRPr sz="1400" b="1">
-                <a:solidFill>
-                  <a:srgbClr val="0F172A"/>
-                </a:solidFill>
-              </a:defRPr>
-            </a:pPr>
-            <a:r>
-              <a:t>4. WebGL Studio &amp; HUD</a:t>
-            </a:r>
-          </a:p>
-          <a:p>
-            <a:pPr>
-              <a:spcBef>
-                <a:spcPts val="300"/>
-              </a:spcBef>
-              <a:defRPr sz="950" b="1">
-                <a:solidFill>
-                  <a:srgbClr val="0284C7"/>
-                </a:solidFill>
-              </a:defRPr>
-            </a:pPr>
-            <a:r>
-              <a:t>PRESENTATION LAYER</a:t>
-            </a:r>
-          </a:p>
-          <a:p>
-            <a:pPr>
-              <a:spcBef>
-                <a:spcPts val="900"/>
-              </a:spcBef>
-              <a:defRPr sz="1100">
-                <a:solidFill>
-                  <a:srgbClr val="475569"/>
-                </a:solidFill>
-              </a:defRPr>
-            </a:pPr>
-            <a:r>
-              <a:t>✓ Three.js Photorealistic 3D</a:t>
-            </a:r>
-          </a:p>
-          <a:p>
-            <a:pPr>
-              <a:spcBef>
-                <a:spcPts val="900"/>
-              </a:spcBef>
-              <a:defRPr sz="1100">
-                <a:solidFill>
-                  <a:srgbClr val="475569"/>
-                </a:solidFill>
-              </a:defRPr>
-            </a:pPr>
-            <a:r>
-              <a:t>✓ Telescopic Drawer Kinematics</a:t>
-            </a:r>
-          </a:p>
-          <a:p>
-            <a:pPr>
-              <a:spcBef>
-                <a:spcPts val="900"/>
-              </a:spcBef>
-              <a:defRPr sz="1100">
-                <a:solidFill>
-                  <a:srgbClr val="475569"/>
-                </a:solidFill>
-              </a:defRPr>
-            </a:pPr>
-            <a:r>
-              <a:t>✓ 60 FPS Oscilloscope Canvas</a:t>
-            </a:r>
-          </a:p>
-          <a:p>
-            <a:pPr>
-              <a:spcBef>
-                <a:spcPts val="900"/>
-              </a:spcBef>
-              <a:defRPr sz="1100">
-                <a:solidFill>
-                  <a:srgbClr val="475569"/>
-                </a:solidFill>
-              </a:defRPr>
-            </a:pPr>
-            <a:r>
-              <a:t>✓ Dual Circular HUD Dials</a:t>
-            </a:r>
-          </a:p>
-          <a:p>
-            <a:pPr>
-              <a:spcBef>
-                <a:spcPts val="900"/>
-              </a:spcBef>
-              <a:defRPr sz="1100">
-                <a:solidFill>
-                  <a:srgbClr val="475569"/>
-                </a:solidFill>
-              </a:defRPr>
-            </a:pPr>
-            <a:r>
-              <a:t>✓ Next.js App Router (Vercel)</a:t>
-            </a:r>
-          </a:p>
-        </p:txBody>
-      </p:sp>
+        </p:spPr>
+      </p:pic>
     </p:spTree>
   </p:cSld>
   <p:clrMapOvr>
@@ -5143,7 +4261,7 @@
         <p:spPr>
           <a:xfrm>
             <a:off x="731520" y="365760"/>
-            <a:ext cx="10515600" cy="320040"/>
+            <a:ext cx="9144000" cy="320040"/>
           </a:xfrm>
           <a:prstGeom prst="rect">
             <a:avLst/>
@@ -5157,14 +4275,15 @@
           <a:lstStyle/>
           <a:p>
             <a:pPr>
-              <a:defRPr sz="1000" b="1">
+              <a:defRPr sz="950" b="1">
                 <a:solidFill>
                   <a:srgbClr val="0284C7"/>
                 </a:solidFill>
-              </a:defRPr>
-            </a:pPr>
-            <a:r>
-              <a:t>PHYSICS-INFORMED LOGISTICS</a:t>
+                <a:latin typeface="Space Mono"/>
+              </a:defRPr>
+            </a:pPr>
+            <a:r>
+              <a:t>ANALYTICAL MODEL</a:t>
             </a:r>
           </a:p>
         </p:txBody>
@@ -5177,8 +4296,8 @@
         </p:nvSpPr>
         <p:spPr>
           <a:xfrm>
-            <a:off x="731520" y="685800"/>
-            <a:ext cx="10515600" cy="594360"/>
+            <a:off x="731520" y="658368"/>
+            <a:ext cx="9601200" cy="594360"/>
           </a:xfrm>
           <a:prstGeom prst="rect">
             <a:avLst/>
@@ -5192,28 +4311,65 @@
           <a:lstStyle/>
           <a:p>
             <a:pPr>
-              <a:defRPr sz="2600" b="1">
+              <a:defRPr sz="2500" b="1">
                 <a:solidFill>
                   <a:srgbClr val="0F172A"/>
                 </a:solidFill>
-              </a:defRPr>
-            </a:pPr>
-            <a:r>
-              <a:t>Arrhenius Physics: Dynamic Kinetic Shelf-Life Modeling</a:t>
-            </a:r>
-          </a:p>
-        </p:txBody>
-      </p:sp>
-      <p:sp>
-        <p:nvSpPr>
-          <p:cNvPr id="5" name="Rounded Rectangle 4"/>
+                <a:latin typeface="Syne"/>
+              </a:defRPr>
+            </a:pPr>
+            <a:r>
+              <a:t>Arrhenius Physics: Dynamic Kinetic Shelf-Life Formulation</a:t>
+            </a:r>
+          </a:p>
+        </p:txBody>
+      </p:sp>
+      <p:sp>
+        <p:nvSpPr>
+          <p:cNvPr id="5" name="TextBox 4"/>
+          <p:cNvSpPr txBox="1"/>
+          <p:nvPr/>
+        </p:nvSpPr>
+        <p:spPr>
+          <a:xfrm>
+            <a:off x="10515600" y="365760"/>
+            <a:ext cx="1097280" cy="365760"/>
+          </a:xfrm>
+          <a:prstGeom prst="rect">
+            <a:avLst/>
+          </a:prstGeom>
+          <a:noFill/>
+        </p:spPr>
+        <p:txBody>
+          <a:bodyPr wrap="none">
+            <a:spAutoFit/>
+          </a:bodyPr>
+          <a:lstStyle/>
+          <a:p>
+            <a:pPr>
+              <a:defRPr sz="1100">
+                <a:solidFill>
+                  <a:srgbClr val="475569"/>
+                </a:solidFill>
+                <a:latin typeface="Space Mono"/>
+              </a:defRPr>
+            </a:pPr>
+            <a:r>
+              <a:t>04 / 09</a:t>
+            </a:r>
+          </a:p>
+        </p:txBody>
+      </p:sp>
+      <p:sp>
+        <p:nvSpPr>
+          <p:cNvPr id="6" name="Rounded Rectangle 5"/>
           <p:cNvSpPr/>
           <p:nvPr/>
         </p:nvSpPr>
         <p:spPr>
           <a:xfrm>
-            <a:off x="731520" y="1463040"/>
-            <a:ext cx="5120640" cy="4663440"/>
+            <a:off x="731520" y="1371600"/>
+            <a:ext cx="5120640" cy="4937760"/>
           </a:xfrm>
           <a:prstGeom prst="roundRect">
             <a:avLst/>
@@ -5251,14 +4407,14 @@
       </p:sp>
       <p:sp>
         <p:nvSpPr>
-          <p:cNvPr id="6" name="TextBox 5"/>
+          <p:cNvPr id="7" name="TextBox 6"/>
           <p:cNvSpPr txBox="1"/>
           <p:nvPr/>
         </p:nvSpPr>
         <p:spPr>
           <a:xfrm>
-            <a:off x="960120" y="1645920"/>
-            <a:ext cx="4663440" cy="4297680"/>
+            <a:off x="914400" y="1554480"/>
+            <a:ext cx="4754880" cy="4572000"/>
           </a:xfrm>
           <a:prstGeom prst="rect">
             <a:avLst/>
@@ -5272,14 +4428,15 @@
           <a:lstStyle/>
           <a:p>
             <a:pPr>
-              <a:defRPr sz="1600" b="1">
+              <a:defRPr sz="1500" b="1">
                 <a:solidFill>
                   <a:srgbClr val="0F172A"/>
                 </a:solidFill>
-              </a:defRPr>
-            </a:pPr>
-            <a:r>
-              <a:t>The Arrhenius Kinetic Formulation</a:t>
+                <a:latin typeface="Syne"/>
+              </a:defRPr>
+            </a:pPr>
+            <a:r>
+              <a:t>The Arrhenius Kinetic Equation</a:t>
             </a:r>
           </a:p>
           <a:p>
@@ -5287,14 +4444,15 @@
               <a:spcBef>
                 <a:spcPts val="800"/>
               </a:spcBef>
-              <a:defRPr sz="1400" b="1">
+              <a:defRPr sz="1200" b="1">
                 <a:solidFill>
                   <a:srgbClr val="0284C7"/>
                 </a:solidFill>
-              </a:defRPr>
-            </a:pPr>
-            <a:r>
-              <a:t>AF = exp [ (Ea / kB) · (1/T_ref - 1/T_stress) ]</a:t>
+                <a:latin typeface="Space Mono"/>
+              </a:defRPr>
+            </a:pPr>
+            <a:r>
+              <a:t>AF = exp [ (Ea / kB) · (1/T_nom - 1/T_stress) ]</a:t>
             </a:r>
           </a:p>
           <a:p>
@@ -5302,70 +4460,73 @@
               <a:spcBef>
                 <a:spcPts val="1000"/>
               </a:spcBef>
-              <a:defRPr sz="1100">
+              <a:defRPr sz="1050">
                 <a:solidFill>
                   <a:srgbClr val="475569"/>
                 </a:solidFill>
-              </a:defRPr>
-            </a:pPr>
-            <a:r>
-              <a:t>• Activation Energy (Ea): 0.60 eV (Standard semiconductor thermal degradation)</a:t>
+                <a:latin typeface="Outfit"/>
+              </a:defRPr>
+            </a:pPr>
+            <a:r>
+              <a:t>• Ea = 0.60 eV: Empirical activation energy for silicon thermal aging.</a:t>
             </a:r>
             <a:br/>
             <a:r>
-              <a:t>• Boltzmann Constant (kB): 8.6173 × 10^-5 eV/K</a:t>
+              <a:t>• kB = 8.6173 × 10^-5 eV/K: Boltzmann constant.</a:t>
             </a:r>
             <a:br/>
             <a:r>
-              <a:t>• Baseline Reference Temp (T_ref): 298.15 K (25.0°C)</a:t>
+              <a:t>• T_nom = 298.15 K: Standard nominal storage (25.0°C).</a:t>
             </a:r>
             <a:br/>
             <a:r>
-              <a:t>• Chamber Temp (T_stress): Real-time EMA sensor telemetry</a:t>
+              <a:t>• T_stress: Integrated real-time temperature from filtered sensor bus.</a:t>
             </a:r>
           </a:p>
           <a:p>
             <a:pPr>
               <a:spcBef>
-                <a:spcPts val="1400"/>
+                <a:spcPts val="1200"/>
               </a:spcBef>
-              <a:defRPr sz="1400" b="1">
+              <a:defRPr sz="1300" b="1">
                 <a:solidFill>
                   <a:srgbClr val="0F172A"/>
                 </a:solidFill>
-              </a:defRPr>
-            </a:pPr>
-            <a:r>
-              <a:t>Dynamic FEFO Dispatch Optimization</a:t>
+                <a:latin typeface="Syne"/>
+              </a:defRPr>
+            </a:pPr>
+            <a:r>
+              <a:t>Excursion Stress Integration</a:t>
             </a:r>
           </a:p>
           <a:p>
             <a:pPr>
               <a:spcBef>
-                <a:spcPts val="600"/>
+                <a:spcPts val="400"/>
               </a:spcBef>
-              <a:defRPr sz="1050">
+              <a:defRPr sz="1000">
                 <a:solidFill>
                   <a:srgbClr val="475569"/>
                 </a:solidFill>
-              </a:defRPr>
-            </a:pPr>
-            <a:r>
-              <a:t>Instead of relying on static manufacturer calendar dates, the system continuously integrates cumulative thermal excursion stress. When a storage drawer experiences 45°C ambient spikes, the degradation rate increases by 4.2×. The system automatically recalculates adjusted shelf life and promotes affected batches to the top of the dispatch queue.</a:t>
-            </a:r>
-          </a:p>
-        </p:txBody>
-      </p:sp>
-      <p:sp>
-        <p:nvSpPr>
-          <p:cNvPr id="7" name="Rounded Rectangle 6"/>
+                <a:latin typeface="Outfit"/>
+              </a:defRPr>
+            </a:pPr>
+            <a:r>
+              <a:t>At 45°C, the acceleration factor climbs to 4.2×, degrading component reliability 400% faster than nominal warehouse conditions. The engine automatically integrates cumulative stress hours, adjusting remaining shelf-life days and promoting reels in the FEFO pick queue.</a:t>
+            </a:r>
+          </a:p>
+        </p:txBody>
+      </p:sp>
+      <p:sp>
+        <p:nvSpPr>
+          <p:cNvPr id="8" name="Rounded Rectangle 7"/>
           <p:cNvSpPr/>
           <p:nvPr/>
         </p:nvSpPr>
         <p:spPr>
           <a:xfrm>
-            <a:off x="6126480" y="1463040"/>
-            <a:ext cx="5303520" cy="4663440"/>
+            <a:off x="6126480" y="1371600"/>
+            <a:ext cx="5303520" cy="4937760"/>
           </a:xfrm>
           <a:prstGeom prst="roundRect">
             <a:avLst/>
@@ -5403,7 +4564,7 @@
       </p:sp>
       <p:pic>
         <p:nvPicPr>
-          <p:cNvPr id="8" name="Picture 7" descr="arrhenius_graph.png"/>
+          <p:cNvPr id="9" name="Picture 8" descr="arrhenius_graph.png"/>
           <p:cNvPicPr>
             <a:picLocks noChangeAspect="1"/>
           </p:cNvPicPr>
@@ -5417,7 +4578,7 @@
         </p:blipFill>
         <p:spPr>
           <a:xfrm>
-            <a:off x="6309360" y="1737360"/>
+            <a:off x="6309360" y="1554480"/>
             <a:ext cx="4937760" cy="3127248"/>
           </a:xfrm>
           <a:prstGeom prst="rect">
@@ -5495,7 +4656,7 @@
         <p:spPr>
           <a:xfrm>
             <a:off x="731520" y="365760"/>
-            <a:ext cx="10515600" cy="320040"/>
+            <a:ext cx="9144000" cy="320040"/>
           </a:xfrm>
           <a:prstGeom prst="rect">
             <a:avLst/>
@@ -5509,14 +4670,15 @@
           <a:lstStyle/>
           <a:p>
             <a:pPr>
-              <a:defRPr sz="1000" b="1">
+              <a:defRPr sz="950" b="1">
                 <a:solidFill>
                   <a:srgbClr val="0284C7"/>
                 </a:solidFill>
-              </a:defRPr>
-            </a:pPr>
-            <a:r>
-              <a:t>INTERACTIVE USER INTERFACE</a:t>
+                <a:latin typeface="Space Mono"/>
+              </a:defRPr>
+            </a:pPr>
+            <a:r>
+              <a:t>KINEMATICS &amp; MATERIALS</a:t>
             </a:r>
           </a:p>
         </p:txBody>
@@ -5529,8 +4691,8 @@
         </p:nvSpPr>
         <p:spPr>
           <a:xfrm>
-            <a:off x="731520" y="685800"/>
-            <a:ext cx="10515600" cy="594360"/>
+            <a:off x="731520" y="658368"/>
+            <a:ext cx="9601200" cy="594360"/>
           </a:xfrm>
           <a:prstGeom prst="rect">
             <a:avLst/>
@@ -5544,28 +4706,65 @@
           <a:lstStyle/>
           <a:p>
             <a:pPr>
-              <a:defRPr sz="2600" b="1">
+              <a:defRPr sz="2500" b="1">
                 <a:solidFill>
                   <a:srgbClr val="0F172A"/>
                 </a:solidFill>
-              </a:defRPr>
-            </a:pPr>
-            <a:r>
-              <a:t>Photorealistic 3D Cabinet &amp; Cleanroom Laboratory Portal</a:t>
-            </a:r>
-          </a:p>
-        </p:txBody>
-      </p:sp>
-      <p:sp>
-        <p:nvSpPr>
-          <p:cNvPr id="5" name="Rounded Rectangle 4"/>
+                <a:latin typeface="Syne"/>
+              </a:defRPr>
+            </a:pPr>
+            <a:r>
+              <a:t>Hardware-Accurate Three.js 3D Matrix &amp; Mechanical Bay</a:t>
+            </a:r>
+          </a:p>
+        </p:txBody>
+      </p:sp>
+      <p:sp>
+        <p:nvSpPr>
+          <p:cNvPr id="5" name="TextBox 4"/>
+          <p:cNvSpPr txBox="1"/>
+          <p:nvPr/>
+        </p:nvSpPr>
+        <p:spPr>
+          <a:xfrm>
+            <a:off x="10515600" y="365760"/>
+            <a:ext cx="1097280" cy="365760"/>
+          </a:xfrm>
+          <a:prstGeom prst="rect">
+            <a:avLst/>
+          </a:prstGeom>
+          <a:noFill/>
+        </p:spPr>
+        <p:txBody>
+          <a:bodyPr wrap="none">
+            <a:spAutoFit/>
+          </a:bodyPr>
+          <a:lstStyle/>
+          <a:p>
+            <a:pPr>
+              <a:defRPr sz="1100">
+                <a:solidFill>
+                  <a:srgbClr val="475569"/>
+                </a:solidFill>
+                <a:latin typeface="Space Mono"/>
+              </a:defRPr>
+            </a:pPr>
+            <a:r>
+              <a:t>05 / 09</a:t>
+            </a:r>
+          </a:p>
+        </p:txBody>
+      </p:sp>
+      <p:sp>
+        <p:nvSpPr>
+          <p:cNvPr id="6" name="Rounded Rectangle 5"/>
           <p:cNvSpPr/>
           <p:nvPr/>
         </p:nvSpPr>
         <p:spPr>
           <a:xfrm>
-            <a:off x="731520" y="1463040"/>
-            <a:ext cx="5120640" cy="4663440"/>
+            <a:off x="731520" y="1371600"/>
+            <a:ext cx="5120640" cy="4937760"/>
           </a:xfrm>
           <a:prstGeom prst="roundRect">
             <a:avLst/>
@@ -5603,14 +4802,14 @@
       </p:sp>
       <p:sp>
         <p:nvSpPr>
-          <p:cNvPr id="6" name="TextBox 5"/>
+          <p:cNvPr id="7" name="TextBox 6"/>
           <p:cNvSpPr txBox="1"/>
           <p:nvPr/>
         </p:nvSpPr>
         <p:spPr>
           <a:xfrm>
-            <a:off x="960120" y="1645920"/>
-            <a:ext cx="4663440" cy="4297680"/>
+            <a:off x="914400" y="1554480"/>
+            <a:ext cx="4754880" cy="4572000"/>
           </a:xfrm>
           <a:prstGeom prst="rect">
             <a:avLst/>
@@ -5624,14 +4823,15 @@
           <a:lstStyle/>
           <a:p>
             <a:pPr>
-              <a:defRPr sz="1600" b="1">
+              <a:defRPr sz="1500" b="1">
                 <a:solidFill>
                   <a:srgbClr val="0F172A"/>
                 </a:solidFill>
-              </a:defRPr>
-            </a:pPr>
-            <a:r>
-              <a:t>Hardware-Accurate Three.js Visual Matrix</a:t>
+                <a:latin typeface="Syne"/>
+              </a:defRPr>
+            </a:pPr>
+            <a:r>
+              <a:t>Physical Enclosure Kinematics</a:t>
             </a:r>
           </a:p>
           <a:p>
@@ -5643,6 +4843,7 @@
                 <a:solidFill>
                   <a:srgbClr val="0284C7"/>
                 </a:solidFill>
+                <a:latin typeface="Syne"/>
               </a:defRPr>
             </a:pPr>
             <a:r>
@@ -5651,14 +4852,18 @@
           </a:p>
           <a:p>
             <a:pPr>
+              <a:spcBef>
+                <a:spcPts val="200"/>
+              </a:spcBef>
               <a:defRPr sz="1000">
                 <a:solidFill>
                   <a:srgbClr val="475569"/>
                 </a:solidFill>
-              </a:defRPr>
-            </a:pPr>
-            <a:r>
-              <a:t>Operators can directly click on any 3D drawer faceplate in the WebGL viewport to smoothly slide the telescopic drawer open.</a:t>
+                <a:latin typeface="Outfit"/>
+              </a:defRPr>
+            </a:pPr>
+            <a:r>
+              <a:t>Clicking any 3D drawer faceplate in the WebGL viewport raycasts coordinates and slides the drawer body open along the Z-axis.</a:t>
             </a:r>
           </a:p>
           <a:p>
@@ -5670,6 +4875,7 @@
                 <a:solidFill>
                   <a:srgbClr val="0284C7"/>
                 </a:solidFill>
+                <a:latin typeface="Syne"/>
               </a:defRPr>
             </a:pPr>
             <a:r>
@@ -5678,14 +4884,18 @@
           </a:p>
           <a:p>
             <a:pPr>
+              <a:spcBef>
+                <a:spcPts val="200"/>
+              </a:spcBef>
               <a:defRPr sz="1000">
                 <a:solidFill>
                   <a:srgbClr val="475569"/>
                 </a:solidFill>
-              </a:defRPr>
-            </a:pPr>
-            <a:r>
-              <a:t>Brushed surgical stainless steel faceplates, hex mounting rails, internal anti-static ESD foam trays, and silicon IC dies.</a:t>
+                <a:latin typeface="Outfit"/>
+              </a:defRPr>
+            </a:pPr>
+            <a:r>
+              <a:t>Brushed surgical stainless steel faceplates, hex mounting rails, internal ESD foam trays, and silicon IC dies.</a:t>
             </a:r>
           </a:p>
           <a:p>
@@ -5697,22 +4907,27 @@
                 <a:solidFill>
                   <a:srgbClr val="0284C7"/>
                 </a:solidFill>
-              </a:defRPr>
-            </a:pPr>
-            <a:r>
-              <a:t>360° Orbit &amp; Camera Presets</a:t>
-            </a:r>
-          </a:p>
-          <a:p>
-            <a:pPr>
+                <a:latin typeface="Syne"/>
+              </a:defRPr>
+            </a:pPr>
+            <a:r>
+              <a:t>360° Turntable Orbit</a:t>
+            </a:r>
+          </a:p>
+          <a:p>
+            <a:pPr>
+              <a:spcBef>
+                <a:spcPts val="200"/>
+              </a:spcBef>
               <a:defRPr sz="1000">
                 <a:solidFill>
                   <a:srgbClr val="475569"/>
                 </a:solidFill>
-              </a:defRPr>
-            </a:pPr>
-            <a:r>
-              <a:t>Supports fluid touch and mouse drag turntable orbit alongside instant Isometric and Perspective camera views.</a:t>
+                <a:latin typeface="Outfit"/>
+              </a:defRPr>
+            </a:pPr>
+            <a:r>
+              <a:t>Drag-to-rotate orbital controls with camera damping and instant Isometric and Perspective presets.</a:t>
             </a:r>
           </a:p>
           <a:p>
@@ -5724,36 +4939,41 @@
                 <a:solidFill>
                   <a:srgbClr val="0284C7"/>
                 </a:solidFill>
-              </a:defRPr>
-            </a:pPr>
-            <a:r>
-              <a:t>Bay Beacon Lighting</a:t>
-            </a:r>
-          </a:p>
-          <a:p>
-            <a:pPr>
+                <a:latin typeface="Syne"/>
+              </a:defRPr>
+            </a:pPr>
+            <a:r>
+              <a:t>Bay Beacon Guidance</a:t>
+            </a:r>
+          </a:p>
+          <a:p>
+            <a:pPr>
+              <a:spcBef>
+                <a:spcPts val="200"/>
+              </a:spcBef>
               <a:defRPr sz="1000">
                 <a:solidFill>
                   <a:srgbClr val="475569"/>
                 </a:solidFill>
-              </a:defRPr>
-            </a:pPr>
-            <a:r>
-              <a:t>Selecting a component illuminates the exact physical slot with a pulsating LED beacon, guiding warehouse picking with zero delay.</a:t>
-            </a:r>
-          </a:p>
-        </p:txBody>
-      </p:sp>
-      <p:sp>
-        <p:nvSpPr>
-          <p:cNvPr id="7" name="Rounded Rectangle 6"/>
+                <a:latin typeface="Outfit"/>
+              </a:defRPr>
+            </a:pPr>
+            <a:r>
+              <a:t>Selecting a part illuminates the exact drawer bay with an animated pulsating LED beacon, eliminating technician lookup delays.</a:t>
+            </a:r>
+          </a:p>
+        </p:txBody>
+      </p:sp>
+      <p:sp>
+        <p:nvSpPr>
+          <p:cNvPr id="8" name="Rounded Rectangle 7"/>
           <p:cNvSpPr/>
           <p:nvPr/>
         </p:nvSpPr>
         <p:spPr>
           <a:xfrm>
-            <a:off x="6126480" y="1463040"/>
-            <a:ext cx="5303520" cy="4663440"/>
+            <a:off x="6126480" y="1371600"/>
+            <a:ext cx="5303520" cy="4937760"/>
           </a:xfrm>
           <a:prstGeom prst="roundRect">
             <a:avLst/>
@@ -5791,7 +5011,7 @@
       </p:sp>
       <p:pic>
         <p:nvPicPr>
-          <p:cNvPr id="8" name="Picture 7" descr="media_1791208320059.png"/>
+          <p:cNvPr id="9" name="Picture 8" descr="robotic_internal_chassis_1791209909127.jpg"/>
           <p:cNvPicPr>
             <a:picLocks noChangeAspect="1"/>
           </p:cNvPicPr>
@@ -5805,8 +5025,8 @@
         </p:blipFill>
         <p:spPr>
           <a:xfrm>
-            <a:off x="6858000" y="1600200"/>
-            <a:ext cx="2871788" cy="4389120"/>
+            <a:off x="6309360" y="1554480"/>
+            <a:ext cx="4937760" cy="2755959"/>
           </a:xfrm>
           <a:prstGeom prst="rect">
             <a:avLst/>
@@ -5883,7 +5103,7 @@
         <p:spPr>
           <a:xfrm>
             <a:off x="731520" y="365760"/>
-            <a:ext cx="10515600" cy="320040"/>
+            <a:ext cx="9144000" cy="320040"/>
           </a:xfrm>
           <a:prstGeom prst="rect">
             <a:avLst/>
@@ -5897,14 +5117,15 @@
           <a:lstStyle/>
           <a:p>
             <a:pPr>
-              <a:defRPr sz="1000" b="1">
+              <a:defRPr sz="950" b="1">
                 <a:solidFill>
                   <a:srgbClr val="0284C7"/>
                 </a:solidFill>
-              </a:defRPr>
-            </a:pPr>
-            <a:r>
-              <a:t>REAL-TIME HARDWARE CONTROL</a:t>
+                <a:latin typeface="Space Mono"/>
+              </a:defRPr>
+            </a:pPr>
+            <a:r>
+              <a:t>EDGE AUTOMATION</a:t>
             </a:r>
           </a:p>
         </p:txBody>
@@ -5917,8 +5138,8 @@
         </p:nvSpPr>
         <p:spPr>
           <a:xfrm>
-            <a:off x="731520" y="685800"/>
-            <a:ext cx="10515600" cy="594360"/>
+            <a:off x="731520" y="658368"/>
+            <a:ext cx="9601200" cy="594360"/>
           </a:xfrm>
           <a:prstGeom prst="rect">
             <a:avLst/>
@@ -5932,28 +5153,65 @@
           <a:lstStyle/>
           <a:p>
             <a:pPr>
-              <a:defRPr sz="2600" b="1">
+              <a:defRPr sz="2500" b="1">
                 <a:solidFill>
                   <a:srgbClr val="0F172A"/>
                 </a:solidFill>
-              </a:defRPr>
-            </a:pPr>
-            <a:r>
-              <a:t>Closed-Loop Actuation &amp; Edge Jitter Filtering</a:t>
-            </a:r>
-          </a:p>
-        </p:txBody>
-      </p:sp>
-      <p:sp>
-        <p:nvSpPr>
-          <p:cNvPr id="5" name="Rounded Rectangle 4"/>
+                <a:latin typeface="Syne"/>
+              </a:defRPr>
+            </a:pPr>
+            <a:r>
+              <a:t>Closed-Loop Micro-Actuation &amp; EMA Noise Suppression</a:t>
+            </a:r>
+          </a:p>
+        </p:txBody>
+      </p:sp>
+      <p:sp>
+        <p:nvSpPr>
+          <p:cNvPr id="5" name="TextBox 4"/>
+          <p:cNvSpPr txBox="1"/>
+          <p:nvPr/>
+        </p:nvSpPr>
+        <p:spPr>
+          <a:xfrm>
+            <a:off x="10515600" y="365760"/>
+            <a:ext cx="1097280" cy="365760"/>
+          </a:xfrm>
+          <a:prstGeom prst="rect">
+            <a:avLst/>
+          </a:prstGeom>
+          <a:noFill/>
+        </p:spPr>
+        <p:txBody>
+          <a:bodyPr wrap="none">
+            <a:spAutoFit/>
+          </a:bodyPr>
+          <a:lstStyle/>
+          <a:p>
+            <a:pPr>
+              <a:defRPr sz="1100">
+                <a:solidFill>
+                  <a:srgbClr val="475569"/>
+                </a:solidFill>
+                <a:latin typeface="Space Mono"/>
+              </a:defRPr>
+            </a:pPr>
+            <a:r>
+              <a:t>06 / 09</a:t>
+            </a:r>
+          </a:p>
+        </p:txBody>
+      </p:sp>
+      <p:sp>
+        <p:nvSpPr>
+          <p:cNvPr id="6" name="Rounded Rectangle 5"/>
           <p:cNvSpPr/>
           <p:nvPr/>
         </p:nvSpPr>
         <p:spPr>
           <a:xfrm>
-            <a:off x="731520" y="1463040"/>
-            <a:ext cx="5212080" cy="4663440"/>
+            <a:off x="731520" y="1371600"/>
+            <a:ext cx="5212080" cy="4937760"/>
           </a:xfrm>
           <a:prstGeom prst="roundRect">
             <a:avLst/>
@@ -5991,7 +5249,7 @@
       </p:sp>
       <p:pic>
         <p:nvPicPr>
-          <p:cNvPr id="6" name="Picture 5" descr="sensor_filter.png"/>
+          <p:cNvPr id="7" name="Picture 6" descr="sensor_filter.png"/>
           <p:cNvPicPr>
             <a:picLocks noChangeAspect="1"/>
           </p:cNvPicPr>
@@ -6005,7 +5263,7 @@
         </p:blipFill>
         <p:spPr>
           <a:xfrm>
-            <a:off x="868680" y="1645920"/>
+            <a:off x="868680" y="1554480"/>
             <a:ext cx="4937760" cy="3127248"/>
           </a:xfrm>
           <a:prstGeom prst="rect">
@@ -6015,14 +5273,14 @@
       </p:pic>
       <p:sp>
         <p:nvSpPr>
-          <p:cNvPr id="7" name="Rounded Rectangle 6"/>
+          <p:cNvPr id="8" name="Rounded Rectangle 7"/>
           <p:cNvSpPr/>
           <p:nvPr/>
         </p:nvSpPr>
         <p:spPr>
           <a:xfrm>
-            <a:off x="6217920" y="1463040"/>
-            <a:ext cx="5212080" cy="4663440"/>
+            <a:off x="6217920" y="1371600"/>
+            <a:ext cx="5212080" cy="4937760"/>
           </a:xfrm>
           <a:prstGeom prst="roundRect">
             <a:avLst/>
@@ -6060,14 +5318,14 @@
       </p:sp>
       <p:sp>
         <p:nvSpPr>
-          <p:cNvPr id="8" name="TextBox 7"/>
+          <p:cNvPr id="9" name="TextBox 8"/>
           <p:cNvSpPr txBox="1"/>
           <p:nvPr/>
         </p:nvSpPr>
         <p:spPr>
           <a:xfrm>
-            <a:off x="6446520" y="1645920"/>
-            <a:ext cx="4754880" cy="4297680"/>
+            <a:off x="6446520" y="1554480"/>
+            <a:ext cx="4754880" cy="4572000"/>
           </a:xfrm>
           <a:prstGeom prst="rect">
             <a:avLst/>
@@ -6081,14 +5339,15 @@
           <a:lstStyle/>
           <a:p>
             <a:pPr>
-              <a:defRPr sz="1600" b="1">
+              <a:defRPr sz="1500" b="1">
                 <a:solidFill>
                   <a:srgbClr val="0F172A"/>
                 </a:solidFill>
-              </a:defRPr>
-            </a:pPr>
-            <a:r>
-              <a:t>Autonomous Bidirectional Control Loop</a:t>
+                <a:latin typeface="Syne"/>
+              </a:defRPr>
+            </a:pPr>
+            <a:r>
+              <a:t>Autonomous Micro-Actuator Control</a:t>
             </a:r>
           </a:p>
           <a:p>
@@ -6100,22 +5359,27 @@
                 <a:solidFill>
                   <a:srgbClr val="0284C7"/>
                 </a:solidFill>
-              </a:defRPr>
-            </a:pPr>
-            <a:r>
-              <a:t>EMA Telemetry Smoothing (α = 0.18)</a:t>
-            </a:r>
-          </a:p>
-          <a:p>
-            <a:pPr>
+                <a:latin typeface="Syne"/>
+              </a:defRPr>
+            </a:pPr>
+            <a:r>
+              <a:t>EMA Sensor Smoothing (α = 0.18)</a:t>
+            </a:r>
+          </a:p>
+          <a:p>
+            <a:pPr>
+              <a:spcBef>
+                <a:spcPts val="200"/>
+              </a:spcBef>
               <a:defRPr sz="1000">
                 <a:solidFill>
                   <a:srgbClr val="475569"/>
                 </a:solidFill>
-              </a:defRPr>
-            </a:pPr>
-            <a:r>
-              <a:t>Removes transient high-frequency noise from digital sensors (SHT31 / DHT22) while preserving immediate response to genuine thermal excursions.</a:t>
+                <a:latin typeface="Outfit"/>
+              </a:defRPr>
+            </a:pPr>
+            <a:r>
+              <a:t>Suppresses digital quantization jitter without introducing lag, guaranteeing instant detection of real thermal drifts.</a:t>
             </a:r>
           </a:p>
           <a:p>
@@ -6127,22 +5391,27 @@
                 <a:solidFill>
                   <a:srgbClr val="0284C7"/>
                 </a:solidFill>
-              </a:defRPr>
-            </a:pPr>
-            <a:r>
-              <a:t>Peltier Sub-Chamber Cooling (TEC1-12706)</a:t>
-            </a:r>
-          </a:p>
-          <a:p>
-            <a:pPr>
+                <a:latin typeface="Syne"/>
+              </a:defRPr>
+            </a:pPr>
+            <a:r>
+              <a:t>Peltier Thermoelectric Cooling</a:t>
+            </a:r>
+          </a:p>
+          <a:p>
+            <a:pPr>
+              <a:spcBef>
+                <a:spcPts val="200"/>
+              </a:spcBef>
               <a:defRPr sz="1000">
                 <a:solidFill>
                   <a:srgbClr val="475569"/>
                 </a:solidFill>
-              </a:defRPr>
-            </a:pPr>
-            <a:r>
-              <a:t>When temperature exceeds the 28.0°C safety envelope, the backend automatically issues a down-link telecommand to engage 12V 4.2A thermoelectric refrigeration.</a:t>
+                <a:latin typeface="Outfit"/>
+              </a:defRPr>
+            </a:pPr>
+            <a:r>
+              <a:t>When temperature breaches the 28.0°C safety envelope, the system automatically triggers 12V 4.2A solid-state refrigeration.</a:t>
             </a:r>
           </a:p>
           <a:p>
@@ -6154,22 +5423,27 @@
                 <a:solidFill>
                   <a:srgbClr val="0284C7"/>
                 </a:solidFill>
-              </a:defRPr>
-            </a:pPr>
-            <a:r>
-              <a:t>Motorized Damper Exhaust (MG996R Servos)</a:t>
-            </a:r>
-          </a:p>
-          <a:p>
-            <a:pPr>
+                <a:latin typeface="Syne"/>
+              </a:defRPr>
+            </a:pPr>
+            <a:r>
+              <a:t>Motorized Ventilation Dampers</a:t>
+            </a:r>
+          </a:p>
+          <a:p>
+            <a:pPr>
+              <a:spcBef>
+                <a:spcPts val="200"/>
+              </a:spcBef>
               <a:defRPr sz="1000">
                 <a:solidFill>
                   <a:srgbClr val="475569"/>
                 </a:solidFill>
-              </a:defRPr>
-            </a:pPr>
-            <a:r>
-              <a:t>Servo rotates to 90° to open high-volume exhaust dampers when relative humidity crosses 60% RH, venting moisture build-up.</a:t>
+                <a:latin typeface="Outfit"/>
+              </a:defRPr>
+            </a:pPr>
+            <a:r>
+              <a:t>High-torque servos rotate dampers to 90° whenever relative humidity exceeds 60% RH, venting moisture into desiccant paths.</a:t>
             </a:r>
           </a:p>
           <a:p>
@@ -6181,22 +5455,27 @@
                 <a:solidFill>
                   <a:srgbClr val="0284C7"/>
                 </a:solidFill>
-              </a:defRPr>
-            </a:pPr>
-            <a:r>
-              <a:t>Manual Override &amp; Audit Log</a:t>
-            </a:r>
-          </a:p>
-          <a:p>
-            <a:pPr>
+                <a:latin typeface="Syne"/>
+              </a:defRPr>
+            </a:pPr>
+            <a:r>
+              <a:t>Bidirectional Manual Overrides</a:t>
+            </a:r>
+          </a:p>
+          <a:p>
+            <a:pPr>
+              <a:spcBef>
+                <a:spcPts val="200"/>
+              </a:spcBef>
               <a:defRPr sz="1000">
                 <a:solidFill>
                   <a:srgbClr val="475569"/>
                 </a:solidFill>
-              </a:defRPr>
-            </a:pPr>
-            <a:r>
-              <a:t>Operators retain instant one-click toggle controls in the dashboard with cryptographic action logging.</a:t>
+                <a:latin typeface="Outfit"/>
+              </a:defRPr>
+            </a:pPr>
+            <a:r>
+              <a:t>Technicians can manually toggle fans and cooling blocks via dashboard buttons with cryptographic command authentication.</a:t>
             </a:r>
           </a:p>
         </p:txBody>
@@ -6271,7 +5550,7 @@
         <p:spPr>
           <a:xfrm>
             <a:off x="731520" y="365760"/>
-            <a:ext cx="10515600" cy="320040"/>
+            <a:ext cx="9144000" cy="320040"/>
           </a:xfrm>
           <a:prstGeom prst="rect">
             <a:avLst/>
@@ -6285,14 +5564,15 @@
           <a:lstStyle/>
           <a:p>
             <a:pPr>
-              <a:defRPr sz="1000" b="1">
+              <a:defRPr sz="950" b="1">
                 <a:solidFill>
                   <a:srgbClr val="0284C7"/>
                 </a:solidFill>
-              </a:defRPr>
-            </a:pPr>
-            <a:r>
-              <a:t>WAREHOUSE LOGISTICS IMPACT</a:t>
+                <a:latin typeface="Space Mono"/>
+              </a:defRPr>
+            </a:pPr>
+            <a:r>
+              <a:t>INVENTORY OPTIMIZATION</a:t>
             </a:r>
           </a:p>
         </p:txBody>
@@ -6305,8 +5585,8 @@
         </p:nvSpPr>
         <p:spPr>
           <a:xfrm>
-            <a:off x="731520" y="685800"/>
-            <a:ext cx="10515600" cy="594360"/>
+            <a:off x="731520" y="658368"/>
+            <a:ext cx="9601200" cy="594360"/>
           </a:xfrm>
           <a:prstGeom prst="rect">
             <a:avLst/>
@@ -6320,28 +5600,65 @@
           <a:lstStyle/>
           <a:p>
             <a:pPr>
-              <a:defRPr sz="2600" b="1">
+              <a:defRPr sz="2500" b="1">
                 <a:solidFill>
                   <a:srgbClr val="0F172A"/>
                 </a:solidFill>
-              </a:defRPr>
-            </a:pPr>
-            <a:r>
-              <a:t>Stress-Weighted Inventory Allocation &amp; Picking</a:t>
-            </a:r>
-          </a:p>
-        </p:txBody>
-      </p:sp>
-      <p:sp>
-        <p:nvSpPr>
-          <p:cNvPr id="5" name="Rounded Rectangle 4"/>
+                <a:latin typeface="Syne"/>
+              </a:defRPr>
+            </a:pPr>
+            <a:r>
+              <a:t>Stress-Weighted FEFO Logistics &amp; Component Yield</a:t>
+            </a:r>
+          </a:p>
+        </p:txBody>
+      </p:sp>
+      <p:sp>
+        <p:nvSpPr>
+          <p:cNvPr id="5" name="TextBox 4"/>
+          <p:cNvSpPr txBox="1"/>
+          <p:nvPr/>
+        </p:nvSpPr>
+        <p:spPr>
+          <a:xfrm>
+            <a:off x="10515600" y="365760"/>
+            <a:ext cx="1097280" cy="365760"/>
+          </a:xfrm>
+          <a:prstGeom prst="rect">
+            <a:avLst/>
+          </a:prstGeom>
+          <a:noFill/>
+        </p:spPr>
+        <p:txBody>
+          <a:bodyPr wrap="none">
+            <a:spAutoFit/>
+          </a:bodyPr>
+          <a:lstStyle/>
+          <a:p>
+            <a:pPr>
+              <a:defRPr sz="1100">
+                <a:solidFill>
+                  <a:srgbClr val="475569"/>
+                </a:solidFill>
+                <a:latin typeface="Space Mono"/>
+              </a:defRPr>
+            </a:pPr>
+            <a:r>
+              <a:t>07 / 09</a:t>
+            </a:r>
+          </a:p>
+        </p:txBody>
+      </p:sp>
+      <p:sp>
+        <p:nvSpPr>
+          <p:cNvPr id="6" name="Rounded Rectangle 5"/>
           <p:cNvSpPr/>
           <p:nvPr/>
         </p:nvSpPr>
         <p:spPr>
           <a:xfrm>
-            <a:off x="731520" y="1463040"/>
-            <a:ext cx="5212080" cy="4663440"/>
+            <a:off x="731520" y="1371600"/>
+            <a:ext cx="5212080" cy="4937760"/>
           </a:xfrm>
           <a:prstGeom prst="roundRect">
             <a:avLst/>
@@ -6379,7 +5696,7 @@
       </p:sp>
       <p:pic>
         <p:nvPicPr>
-          <p:cNvPr id="6" name="Picture 5" descr="fefo_bars.png"/>
+          <p:cNvPr id="7" name="Picture 6" descr="fefo_bars.png"/>
           <p:cNvPicPr>
             <a:picLocks noChangeAspect="1"/>
           </p:cNvPicPr>
@@ -6393,7 +5710,7 @@
         </p:blipFill>
         <p:spPr>
           <a:xfrm>
-            <a:off x="868680" y="1645920"/>
+            <a:off x="868680" y="1554480"/>
             <a:ext cx="4937760" cy="3127248"/>
           </a:xfrm>
           <a:prstGeom prst="rect">
@@ -6403,14 +5720,14 @@
       </p:pic>
       <p:sp>
         <p:nvSpPr>
-          <p:cNvPr id="7" name="Rounded Rectangle 6"/>
+          <p:cNvPr id="8" name="Rounded Rectangle 7"/>
           <p:cNvSpPr/>
           <p:nvPr/>
         </p:nvSpPr>
         <p:spPr>
           <a:xfrm>
-            <a:off x="6217920" y="1463040"/>
-            <a:ext cx="5212080" cy="4663440"/>
+            <a:off x="6217920" y="1371600"/>
+            <a:ext cx="2514600" cy="2377440"/>
           </a:xfrm>
           <a:prstGeom prst="roundRect">
             <a:avLst/>
@@ -6448,14 +5765,14 @@
       </p:sp>
       <p:sp>
         <p:nvSpPr>
-          <p:cNvPr id="8" name="TextBox 7"/>
+          <p:cNvPr id="9" name="TextBox 8"/>
           <p:cNvSpPr txBox="1"/>
           <p:nvPr/>
         </p:nvSpPr>
         <p:spPr>
           <a:xfrm>
-            <a:off x="6446520" y="1645920"/>
-            <a:ext cx="4754880" cy="4297680"/>
+            <a:off x="6355080" y="1554480"/>
+            <a:ext cx="2240280" cy="2011680"/>
           </a:xfrm>
           <a:prstGeom prst="rect">
             <a:avLst/>
@@ -6469,122 +5786,386 @@
           <a:lstStyle/>
           <a:p>
             <a:pPr>
-              <a:defRPr sz="1600" b="1">
-                <a:solidFill>
-                  <a:srgbClr val="0F172A"/>
-                </a:solidFill>
-              </a:defRPr>
-            </a:pPr>
-            <a:r>
-              <a:t>Operational Metrics &amp; Yield Improvements</a:t>
+              <a:defRPr sz="2800" b="1">
+                <a:solidFill>
+                  <a:srgbClr val="10B981"/>
+                </a:solidFill>
+                <a:latin typeface="Space Mono"/>
+              </a:defRPr>
+            </a:pPr>
+            <a:r>
+              <a:t>99.4%</a:t>
             </a:r>
           </a:p>
           <a:p>
             <a:pPr>
               <a:spcBef>
-                <a:spcPts val="800"/>
+                <a:spcPts val="400"/>
               </a:spcBef>
               <a:defRPr sz="1200" b="1">
                 <a:solidFill>
-                  <a:srgbClr val="10B981"/>
-                </a:solidFill>
-              </a:defRPr>
-            </a:pPr>
-            <a:r>
-              <a:t>99.4% Excursion Prevention</a:t>
-            </a:r>
-          </a:p>
-          <a:p>
-            <a:pPr>
-              <a:defRPr sz="1000">
+                  <a:srgbClr val="0F172A"/>
+                </a:solidFill>
+                <a:latin typeface="Syne"/>
+              </a:defRPr>
+            </a:pPr>
+            <a:r>
+              <a:t>Excursion Suppression</a:t>
+            </a:r>
+          </a:p>
+          <a:p>
+            <a:pPr>
+              <a:spcBef>
+                <a:spcPts val="400"/>
+              </a:spcBef>
+              <a:defRPr sz="950">
                 <a:solidFill>
                   <a:srgbClr val="475569"/>
                 </a:solidFill>
-              </a:defRPr>
-            </a:pPr>
-            <a:r>
-              <a:t>Active closed-loop thermal regulation keeps 99.4% of stored components within IPC/JEDEC J-STD-033 moisture and temperature bounds.</a:t>
+                <a:latin typeface="Outfit"/>
+              </a:defRPr>
+            </a:pPr>
+            <a:r>
+              <a:t>Maintained within JEDEC J-STD-033 moisture limits.</a:t>
+            </a:r>
+          </a:p>
+        </p:txBody>
+      </p:sp>
+      <p:sp>
+        <p:nvSpPr>
+          <p:cNvPr id="10" name="Rounded Rectangle 9"/>
+          <p:cNvSpPr/>
+          <p:nvPr/>
+        </p:nvSpPr>
+        <p:spPr>
+          <a:xfrm>
+            <a:off x="8869680" y="1371600"/>
+            <a:ext cx="2514600" cy="2377440"/>
+          </a:xfrm>
+          <a:prstGeom prst="roundRect">
+            <a:avLst/>
+          </a:prstGeom>
+          <a:solidFill>
+            <a:srgbClr val="FFFFFF"/>
+          </a:solidFill>
+          <a:ln w="12700">
+            <a:solidFill>
+              <a:srgbClr val="E2E8F0"/>
+            </a:solidFill>
+          </a:ln>
+        </p:spPr>
+        <p:style>
+          <a:lnRef idx="1">
+            <a:schemeClr val="accent1"/>
+          </a:lnRef>
+          <a:fillRef idx="3">
+            <a:schemeClr val="accent1"/>
+          </a:fillRef>
+          <a:effectRef idx="2">
+            <a:schemeClr val="accent1"/>
+          </a:effectRef>
+          <a:fontRef idx="minor">
+            <a:schemeClr val="lt1"/>
+          </a:fontRef>
+        </p:style>
+        <p:txBody>
+          <a:bodyPr rtlCol="0" anchor="ctr"/>
+          <a:lstStyle/>
+          <a:p>
+            <a:pPr algn="ctr"/>
+          </a:p>
+        </p:txBody>
+      </p:sp>
+      <p:sp>
+        <p:nvSpPr>
+          <p:cNvPr id="11" name="TextBox 10"/>
+          <p:cNvSpPr txBox="1"/>
+          <p:nvPr/>
+        </p:nvSpPr>
+        <p:spPr>
+          <a:xfrm>
+            <a:off x="9006840" y="1554480"/>
+            <a:ext cx="2240280" cy="2011680"/>
+          </a:xfrm>
+          <a:prstGeom prst="rect">
+            <a:avLst/>
+          </a:prstGeom>
+          <a:noFill/>
+        </p:spPr>
+        <p:txBody>
+          <a:bodyPr wrap="square">
+            <a:spAutoFit/>
+          </a:bodyPr>
+          <a:lstStyle/>
+          <a:p>
+            <a:pPr>
+              <a:defRPr sz="2800" b="1">
+                <a:solidFill>
+                  <a:srgbClr val="0284C7"/>
+                </a:solidFill>
+                <a:latin typeface="Space Mono"/>
+              </a:defRPr>
+            </a:pPr>
+            <a:r>
+              <a:t>87%</a:t>
             </a:r>
           </a:p>
           <a:p>
             <a:pPr>
               <a:spcBef>
-                <a:spcPts val="800"/>
+                <a:spcPts val="400"/>
               </a:spcBef>
               <a:defRPr sz="1200" b="1">
                 <a:solidFill>
-                  <a:srgbClr val="10B981"/>
-                </a:solidFill>
-              </a:defRPr>
-            </a:pPr>
-            <a:r>
-              <a:t>87% Reduction in Solderability Scrappage</a:t>
-            </a:r>
-          </a:p>
-          <a:p>
-            <a:pPr>
-              <a:defRPr sz="1000">
+                  <a:srgbClr val="0F172A"/>
+                </a:solidFill>
+                <a:latin typeface="Syne"/>
+              </a:defRPr>
+            </a:pPr>
+            <a:r>
+              <a:t>Scrap Reduction</a:t>
+            </a:r>
+          </a:p>
+          <a:p>
+            <a:pPr>
+              <a:spcBef>
+                <a:spcPts val="400"/>
+              </a:spcBef>
+              <a:defRPr sz="950">
                 <a:solidFill>
                   <a:srgbClr val="475569"/>
                 </a:solidFill>
-              </a:defRPr>
-            </a:pPr>
-            <a:r>
-              <a:t>Components at risk of degradation are dispatched to assembly lines months before shelf-life expiry thresholds.</a:t>
+                <a:latin typeface="Outfit"/>
+              </a:defRPr>
+            </a:pPr>
+            <a:r>
+              <a:t>Stressed components routed before oxidative failure.</a:t>
+            </a:r>
+          </a:p>
+        </p:txBody>
+      </p:sp>
+      <p:sp>
+        <p:nvSpPr>
+          <p:cNvPr id="12" name="Rounded Rectangle 11"/>
+          <p:cNvSpPr/>
+          <p:nvPr/>
+        </p:nvSpPr>
+        <p:spPr>
+          <a:xfrm>
+            <a:off x="6217920" y="3931920"/>
+            <a:ext cx="2514600" cy="2377440"/>
+          </a:xfrm>
+          <a:prstGeom prst="roundRect">
+            <a:avLst/>
+          </a:prstGeom>
+          <a:solidFill>
+            <a:srgbClr val="FFFFFF"/>
+          </a:solidFill>
+          <a:ln w="12700">
+            <a:solidFill>
+              <a:srgbClr val="E2E8F0"/>
+            </a:solidFill>
+          </a:ln>
+        </p:spPr>
+        <p:style>
+          <a:lnRef idx="1">
+            <a:schemeClr val="accent1"/>
+          </a:lnRef>
+          <a:fillRef idx="3">
+            <a:schemeClr val="accent1"/>
+          </a:fillRef>
+          <a:effectRef idx="2">
+            <a:schemeClr val="accent1"/>
+          </a:effectRef>
+          <a:fontRef idx="minor">
+            <a:schemeClr val="lt1"/>
+          </a:fontRef>
+        </p:style>
+        <p:txBody>
+          <a:bodyPr rtlCol="0" anchor="ctr"/>
+          <a:lstStyle/>
+          <a:p>
+            <a:pPr algn="ctr"/>
+          </a:p>
+        </p:txBody>
+      </p:sp>
+      <p:sp>
+        <p:nvSpPr>
+          <p:cNvPr id="13" name="TextBox 12"/>
+          <p:cNvSpPr txBox="1"/>
+          <p:nvPr/>
+        </p:nvSpPr>
+        <p:spPr>
+          <a:xfrm>
+            <a:off x="6355080" y="4114800"/>
+            <a:ext cx="2240280" cy="2011680"/>
+          </a:xfrm>
+          <a:prstGeom prst="rect">
+            <a:avLst/>
+          </a:prstGeom>
+          <a:noFill/>
+        </p:spPr>
+        <p:txBody>
+          <a:bodyPr wrap="square">
+            <a:spAutoFit/>
+          </a:bodyPr>
+          <a:lstStyle/>
+          <a:p>
+            <a:pPr>
+              <a:defRPr sz="2800" b="1">
+                <a:solidFill>
+                  <a:srgbClr val="0284C7"/>
+                </a:solidFill>
+                <a:latin typeface="Space Mono"/>
+              </a:defRPr>
+            </a:pPr>
+            <a:r>
+              <a:t>&lt; 1 sec</a:t>
             </a:r>
           </a:p>
           <a:p>
             <a:pPr>
               <a:spcBef>
-                <a:spcPts val="800"/>
+                <a:spcPts val="400"/>
               </a:spcBef>
               <a:defRPr sz="1200" b="1">
                 <a:solidFill>
-                  <a:srgbClr val="10B981"/>
-                </a:solidFill>
-              </a:defRPr>
-            </a:pPr>
-            <a:r>
-              <a:t>Sub-Second Pick Verification</a:t>
-            </a:r>
-          </a:p>
-          <a:p>
-            <a:pPr>
-              <a:defRPr sz="1000">
+                  <a:srgbClr val="0F172A"/>
+                </a:solidFill>
+                <a:latin typeface="Syne"/>
+              </a:defRPr>
+            </a:pPr>
+            <a:r>
+              <a:t>Pick Locate Time</a:t>
+            </a:r>
+          </a:p>
+          <a:p>
+            <a:pPr>
+              <a:spcBef>
+                <a:spcPts val="400"/>
+              </a:spcBef>
+              <a:defRPr sz="950">
                 <a:solidFill>
                   <a:srgbClr val="475569"/>
                 </a:solidFill>
-              </a:defRPr>
-            </a:pPr>
-            <a:r>
-              <a:t>Warehouse technicians locate items visually via 3D matrix bay highlights and drawer inspection modals, eliminating manual bin lookups.</a:t>
+                <a:latin typeface="Outfit"/>
+              </a:defRPr>
+            </a:pPr>
+            <a:r>
+              <a:t>3D beacon guide eliminates manual bin lookups.</a:t>
+            </a:r>
+          </a:p>
+        </p:txBody>
+      </p:sp>
+      <p:sp>
+        <p:nvSpPr>
+          <p:cNvPr id="14" name="Rounded Rectangle 13"/>
+          <p:cNvSpPr/>
+          <p:nvPr/>
+        </p:nvSpPr>
+        <p:spPr>
+          <a:xfrm>
+            <a:off x="8869680" y="3931920"/>
+            <a:ext cx="2514600" cy="2377440"/>
+          </a:xfrm>
+          <a:prstGeom prst="roundRect">
+            <a:avLst/>
+          </a:prstGeom>
+          <a:solidFill>
+            <a:srgbClr val="FFFFFF"/>
+          </a:solidFill>
+          <a:ln w="12700">
+            <a:solidFill>
+              <a:srgbClr val="E2E8F0"/>
+            </a:solidFill>
+          </a:ln>
+        </p:spPr>
+        <p:style>
+          <a:lnRef idx="1">
+            <a:schemeClr val="accent1"/>
+          </a:lnRef>
+          <a:fillRef idx="3">
+            <a:schemeClr val="accent1"/>
+          </a:fillRef>
+          <a:effectRef idx="2">
+            <a:schemeClr val="accent1"/>
+          </a:effectRef>
+          <a:fontRef idx="minor">
+            <a:schemeClr val="lt1"/>
+          </a:fontRef>
+        </p:style>
+        <p:txBody>
+          <a:bodyPr rtlCol="0" anchor="ctr"/>
+          <a:lstStyle/>
+          <a:p>
+            <a:pPr algn="ctr"/>
+          </a:p>
+        </p:txBody>
+      </p:sp>
+      <p:sp>
+        <p:nvSpPr>
+          <p:cNvPr id="15" name="TextBox 14"/>
+          <p:cNvSpPr txBox="1"/>
+          <p:nvPr/>
+        </p:nvSpPr>
+        <p:spPr>
+          <a:xfrm>
+            <a:off x="9006840" y="4114800"/>
+            <a:ext cx="2240280" cy="2011680"/>
+          </a:xfrm>
+          <a:prstGeom prst="rect">
+            <a:avLst/>
+          </a:prstGeom>
+          <a:noFill/>
+        </p:spPr>
+        <p:txBody>
+          <a:bodyPr wrap="square">
+            <a:spAutoFit/>
+          </a:bodyPr>
+          <a:lstStyle/>
+          <a:p>
+            <a:pPr>
+              <a:defRPr sz="2800" b="1">
+                <a:solidFill>
+                  <a:srgbClr val="F59E0B"/>
+                </a:solidFill>
+                <a:latin typeface="Space Mono"/>
+              </a:defRPr>
+            </a:pPr>
+            <a:r>
+              <a:t>100%</a:t>
             </a:r>
           </a:p>
           <a:p>
             <a:pPr>
               <a:spcBef>
-                <a:spcPts val="800"/>
+                <a:spcPts val="400"/>
               </a:spcBef>
               <a:defRPr sz="1200" b="1">
                 <a:solidFill>
-                  <a:srgbClr val="10B981"/>
-                </a:solidFill>
-              </a:defRPr>
-            </a:pPr>
-            <a:r>
-              <a:t>Automated Restock Thresholds</a:t>
-            </a:r>
-          </a:p>
-          <a:p>
-            <a:pPr>
-              <a:defRPr sz="1000">
+                  <a:srgbClr val="0F172A"/>
+                </a:solidFill>
+                <a:latin typeface="Syne"/>
+              </a:defRPr>
+            </a:pPr>
+            <a:r>
+              <a:t>Audit Traceability</a:t>
+            </a:r>
+          </a:p>
+          <a:p>
+            <a:pPr>
+              <a:spcBef>
+                <a:spcPts val="400"/>
+              </a:spcBef>
+              <a:defRPr sz="950">
                 <a:solidFill>
                   <a:srgbClr val="475569"/>
                 </a:solidFill>
-              </a:defRPr>
-            </a:pPr>
-            <a:r>
-              <a:t>Configurable automated alerts notify procurement whenever drawer quantities drop below minimum safety stock levels.</a:t>
+                <a:latin typeface="Outfit"/>
+              </a:defRPr>
+            </a:pPr>
+            <a:r>
+              <a:t>Cryptographic ESP32 HMAC history per component.</a:t>
             </a:r>
           </a:p>
         </p:txBody>
@@ -6659,7 +6240,7 @@
         <p:spPr>
           <a:xfrm>
             <a:off x="731520" y="365760"/>
-            <a:ext cx="10515600" cy="320040"/>
+            <a:ext cx="9144000" cy="320040"/>
           </a:xfrm>
           <a:prstGeom prst="rect">
             <a:avLst/>
@@ -6673,10 +6254,11 @@
           <a:lstStyle/>
           <a:p>
             <a:pPr>
-              <a:defRPr sz="1000" b="1">
+              <a:defRPr sz="950" b="1">
                 <a:solidFill>
                   <a:srgbClr val="0284C7"/>
                 </a:solidFill>
+                <a:latin typeface="Space Mono"/>
               </a:defRPr>
             </a:pPr>
             <a:r>
@@ -6693,8 +6275,8 @@
         </p:nvSpPr>
         <p:spPr>
           <a:xfrm>
-            <a:off x="731520" y="685800"/>
-            <a:ext cx="10515600" cy="594360"/>
+            <a:off x="731520" y="658368"/>
+            <a:ext cx="9601200" cy="594360"/>
           </a:xfrm>
           <a:prstGeom prst="rect">
             <a:avLst/>
@@ -6708,10 +6290,11 @@
           <a:lstStyle/>
           <a:p>
             <a:pPr>
-              <a:defRPr sz="2600" b="1">
+              <a:defRPr sz="2500" b="1">
                 <a:solidFill>
                   <a:srgbClr val="0F172A"/>
                 </a:solidFill>
+                <a:latin typeface="Syne"/>
               </a:defRPr>
             </a:pPr>
             <a:r>
@@ -6722,14 +6305,50 @@
       </p:sp>
       <p:sp>
         <p:nvSpPr>
-          <p:cNvPr id="5" name="Rounded Rectangle 4"/>
+          <p:cNvPr id="5" name="TextBox 4"/>
+          <p:cNvSpPr txBox="1"/>
+          <p:nvPr/>
+        </p:nvSpPr>
+        <p:spPr>
+          <a:xfrm>
+            <a:off x="10515600" y="365760"/>
+            <a:ext cx="1097280" cy="365760"/>
+          </a:xfrm>
+          <a:prstGeom prst="rect">
+            <a:avLst/>
+          </a:prstGeom>
+          <a:noFill/>
+        </p:spPr>
+        <p:txBody>
+          <a:bodyPr wrap="none">
+            <a:spAutoFit/>
+          </a:bodyPr>
+          <a:lstStyle/>
+          <a:p>
+            <a:pPr>
+              <a:defRPr sz="1100">
+                <a:solidFill>
+                  <a:srgbClr val="475569"/>
+                </a:solidFill>
+                <a:latin typeface="Space Mono"/>
+              </a:defRPr>
+            </a:pPr>
+            <a:r>
+              <a:t>08 / 09</a:t>
+            </a:r>
+          </a:p>
+        </p:txBody>
+      </p:sp>
+      <p:sp>
+        <p:nvSpPr>
+          <p:cNvPr id="6" name="Rounded Rectangle 5"/>
           <p:cNvSpPr/>
           <p:nvPr/>
         </p:nvSpPr>
         <p:spPr>
           <a:xfrm>
-            <a:off x="731520" y="1463040"/>
-            <a:ext cx="2560320" cy="4663440"/>
+            <a:off x="731520" y="1371600"/>
+            <a:ext cx="2560320" cy="4937760"/>
           </a:xfrm>
           <a:prstGeom prst="roundRect">
             <a:avLst/>
@@ -6767,14 +6386,14 @@
       </p:sp>
       <p:sp>
         <p:nvSpPr>
-          <p:cNvPr id="6" name="TextBox 5"/>
+          <p:cNvPr id="7" name="TextBox 6"/>
           <p:cNvSpPr txBox="1"/>
           <p:nvPr/>
         </p:nvSpPr>
         <p:spPr>
           <a:xfrm>
-            <a:off x="896112" y="1645920"/>
-            <a:ext cx="2231136" cy="4297680"/>
+            <a:off x="896112" y="1554480"/>
+            <a:ext cx="2231136" cy="4572000"/>
           </a:xfrm>
           <a:prstGeom prst="rect">
             <a:avLst/>
@@ -6792,10 +6411,27 @@
                 <a:solidFill>
                   <a:srgbClr val="0F172A"/>
                 </a:solidFill>
-              </a:defRPr>
-            </a:pPr>
-            <a:r>
-              <a:t>Frontend (Next.js 16 + Three.js)</a:t>
+                <a:latin typeface="Syne"/>
+              </a:defRPr>
+            </a:pPr>
+            <a:r>
+              <a:t>Next.js 16 + Turbopack</a:t>
+            </a:r>
+          </a:p>
+          <a:p>
+            <a:pPr>
+              <a:spcBef>
+                <a:spcPts val="200"/>
+              </a:spcBef>
+              <a:defRPr sz="900" b="1">
+                <a:solidFill>
+                  <a:srgbClr val="0284C7"/>
+                </a:solidFill>
+                <a:latin typeface="Space Mono"/>
+              </a:defRPr>
+            </a:pPr>
+            <a:r>
+              <a:t>FRONTEND ENGINEERING</a:t>
             </a:r>
           </a:p>
           <a:p>
@@ -6803,14 +6439,15 @@
               <a:spcBef>
                 <a:spcPts val="800"/>
               </a:spcBef>
-              <a:defRPr sz="1050">
+              <a:defRPr sz="1000">
                 <a:solidFill>
                   <a:srgbClr val="475569"/>
                 </a:solidFill>
-              </a:defRPr>
-            </a:pPr>
-            <a:r>
-              <a:t>• Turbopack Static &amp; Dynamic Prerendering</a:t>
+                <a:latin typeface="Outfit"/>
+              </a:defRPr>
+            </a:pPr>
+            <a:r>
+              <a:t>• 17/17 routes prerendered cleanly</a:t>
             </a:r>
           </a:p>
           <a:p>
@@ -6818,14 +6455,15 @@
               <a:spcBef>
                 <a:spcPts val="800"/>
               </a:spcBef>
-              <a:defRPr sz="1050">
+              <a:defRPr sz="1000">
                 <a:solidFill>
                   <a:srgbClr val="475569"/>
                 </a:solidFill>
-              </a:defRPr>
-            </a:pPr>
-            <a:r>
-              <a:t>• 17/17 Routes Fully Verified</a:t>
+                <a:latin typeface="Outfit"/>
+              </a:defRPr>
+            </a:pPr>
+            <a:r>
+              <a:t>• Cleanroom Studio light theme</a:t>
             </a:r>
           </a:p>
           <a:p>
@@ -6833,14 +6471,15 @@
               <a:spcBef>
                 <a:spcPts val="800"/>
               </a:spcBef>
-              <a:defRPr sz="1050">
+              <a:defRPr sz="1000">
                 <a:solidFill>
                   <a:srgbClr val="475569"/>
                 </a:solidFill>
-              </a:defRPr>
-            </a:pPr>
-            <a:r>
-              <a:t>• Tailwind CSS Cleanroom Laboratory Theme</a:t>
+                <a:latin typeface="Outfit"/>
+              </a:defRPr>
+            </a:pPr>
+            <a:r>
+              <a:t>• Three.js WebGL 3D Matrix</a:t>
             </a:r>
           </a:p>
           <a:p>
@@ -6848,10 +6487,11 @@
               <a:spcBef>
                 <a:spcPts val="800"/>
               </a:spcBef>
-              <a:defRPr sz="1050">
+              <a:defRPr sz="1000">
                 <a:solidFill>
                   <a:srgbClr val="475569"/>
                 </a:solidFill>
+                <a:latin typeface="Outfit"/>
               </a:defRPr>
             </a:pPr>
             <a:r>
@@ -6863,28 +6503,29 @@
               <a:spcBef>
                 <a:spcPts val="800"/>
               </a:spcBef>
-              <a:defRPr sz="1050">
+              <a:defRPr sz="1000">
                 <a:solidFill>
                   <a:srgbClr val="475569"/>
                 </a:solidFill>
-              </a:defRPr>
-            </a:pPr>
-            <a:r>
-              <a:t>• Hosted &amp; Scaled on Vercel Edge</a:t>
-            </a:r>
-          </a:p>
-        </p:txBody>
-      </p:sp>
-      <p:sp>
-        <p:nvSpPr>
-          <p:cNvPr id="7" name="Rounded Rectangle 6"/>
+                <a:latin typeface="Outfit"/>
+              </a:defRPr>
+            </a:pPr>
+            <a:r>
+              <a:t>• Hosted on Vercel Edge Global CDN</a:t>
+            </a:r>
+          </a:p>
+        </p:txBody>
+      </p:sp>
+      <p:sp>
+        <p:nvSpPr>
+          <p:cNvPr id="8" name="Rounded Rectangle 7"/>
           <p:cNvSpPr/>
           <p:nvPr/>
         </p:nvSpPr>
         <p:spPr>
           <a:xfrm>
-            <a:off x="3429000" y="1463040"/>
-            <a:ext cx="2560320" cy="4663440"/>
+            <a:off x="3429000" y="1371600"/>
+            <a:ext cx="2560320" cy="4937760"/>
           </a:xfrm>
           <a:prstGeom prst="roundRect">
             <a:avLst/>
@@ -6922,14 +6563,14 @@
       </p:sp>
       <p:sp>
         <p:nvSpPr>
-          <p:cNvPr id="8" name="TextBox 7"/>
+          <p:cNvPr id="9" name="TextBox 8"/>
           <p:cNvSpPr txBox="1"/>
           <p:nvPr/>
         </p:nvSpPr>
         <p:spPr>
           <a:xfrm>
-            <a:off x="3593592" y="1645920"/>
-            <a:ext cx="2231136" cy="4297680"/>
+            <a:off x="3593592" y="1554480"/>
+            <a:ext cx="2231136" cy="4572000"/>
           </a:xfrm>
           <a:prstGeom prst="rect">
             <a:avLst/>
@@ -6947,10 +6588,27 @@
                 <a:solidFill>
                   <a:srgbClr val="0F172A"/>
                 </a:solidFill>
-              </a:defRPr>
-            </a:pPr>
-            <a:r>
-              <a:t>Backend (FastAPI &amp; WebSockets)</a:t>
+                <a:latin typeface="Syne"/>
+              </a:defRPr>
+            </a:pPr>
+            <a:r>
+              <a:t>FastAPI + WebSockets</a:t>
+            </a:r>
+          </a:p>
+          <a:p>
+            <a:pPr>
+              <a:spcBef>
+                <a:spcPts val="200"/>
+              </a:spcBef>
+              <a:defRPr sz="900" b="1">
+                <a:solidFill>
+                  <a:srgbClr val="0284C7"/>
+                </a:solidFill>
+                <a:latin typeface="Space Mono"/>
+              </a:defRPr>
+            </a:pPr>
+            <a:r>
+              <a:t>BACKEND DAEMON</a:t>
             </a:r>
           </a:p>
           <a:p>
@@ -6958,14 +6616,15 @@
               <a:spcBef>
                 <a:spcPts val="800"/>
               </a:spcBef>
-              <a:defRPr sz="1050">
+              <a:defRPr sz="1000">
                 <a:solidFill>
                   <a:srgbClr val="475569"/>
                 </a:solidFill>
-              </a:defRPr>
-            </a:pPr>
-            <a:r>
-              <a:t>• Asynchronous Event-Driven Architecture</a:t>
+                <a:latin typeface="Outfit"/>
+              </a:defRPr>
+            </a:pPr>
+            <a:r>
+              <a:t>• Asynchronous non-blocking architecture</a:t>
             </a:r>
           </a:p>
           <a:p>
@@ -6973,14 +6632,15 @@
               <a:spcBef>
                 <a:spcPts val="800"/>
               </a:spcBef>
-              <a:defRPr sz="1050">
+              <a:defRPr sz="1000">
                 <a:solidFill>
                   <a:srgbClr val="475569"/>
                 </a:solidFill>
-              </a:defRPr>
-            </a:pPr>
-            <a:r>
-              <a:t>• WebSocket Push Updates (&lt;10ms broadcast)</a:t>
+                <a:latin typeface="Outfit"/>
+              </a:defRPr>
+            </a:pPr>
+            <a:r>
+              <a:t>• Sub-10ms broadcast event loop</a:t>
             </a:r>
           </a:p>
           <a:p>
@@ -6988,14 +6648,15 @@
               <a:spcBef>
                 <a:spcPts val="800"/>
               </a:spcBef>
-              <a:defRPr sz="1050">
+              <a:defRPr sz="1000">
                 <a:solidFill>
                   <a:srgbClr val="475569"/>
                 </a:solidFill>
-              </a:defRPr>
-            </a:pPr>
-            <a:r>
-              <a:t>• ESP32 HMAC Signature Verification</a:t>
+                <a:latin typeface="Outfit"/>
+              </a:defRPr>
+            </a:pPr>
+            <a:r>
+              <a:t>• ESP32 HMAC-SHA256 signature auth</a:t>
             </a:r>
           </a:p>
           <a:p>
@@ -7003,14 +6664,15 @@
               <a:spcBef>
                 <a:spcPts val="800"/>
               </a:spcBef>
-              <a:defRPr sz="1050">
+              <a:defRPr sz="1000">
                 <a:solidFill>
                   <a:srgbClr val="475569"/>
                 </a:solidFill>
-              </a:defRPr>
-            </a:pPr>
-            <a:r>
-              <a:t>• Arrhenius Physics Calculation Microservice</a:t>
+                <a:latin typeface="Outfit"/>
+              </a:defRPr>
+            </a:pPr>
+            <a:r>
+              <a:t>• Kinetic Arrhenius microservice</a:t>
             </a:r>
           </a:p>
           <a:p>
@@ -7018,28 +6680,29 @@
               <a:spcBef>
                 <a:spcPts val="800"/>
               </a:spcBef>
-              <a:defRPr sz="1050">
+              <a:defRPr sz="1000">
                 <a:solidFill>
                   <a:srgbClr val="475569"/>
                 </a:solidFill>
-              </a:defRPr>
-            </a:pPr>
-            <a:r>
-              <a:t>• SQLite / PostgreSQL Component Ledger</a:t>
-            </a:r>
-          </a:p>
-        </p:txBody>
-      </p:sp>
-      <p:sp>
-        <p:nvSpPr>
-          <p:cNvPr id="9" name="Rounded Rectangle 8"/>
+                <a:latin typeface="Outfit"/>
+              </a:defRPr>
+            </a:pPr>
+            <a:r>
+              <a:t>• SQLite / PostgreSQL ledger</a:t>
+            </a:r>
+          </a:p>
+        </p:txBody>
+      </p:sp>
+      <p:sp>
+        <p:nvSpPr>
+          <p:cNvPr id="10" name="Rounded Rectangle 9"/>
           <p:cNvSpPr/>
           <p:nvPr/>
         </p:nvSpPr>
         <p:spPr>
           <a:xfrm>
-            <a:off x="6126480" y="1463040"/>
-            <a:ext cx="2560320" cy="4663440"/>
+            <a:off x="6126480" y="1371600"/>
+            <a:ext cx="2560320" cy="4937760"/>
           </a:xfrm>
           <a:prstGeom prst="roundRect">
             <a:avLst/>
@@ -7077,14 +6740,14 @@
       </p:sp>
       <p:sp>
         <p:nvSpPr>
-          <p:cNvPr id="10" name="TextBox 9"/>
+          <p:cNvPr id="11" name="TextBox 10"/>
           <p:cNvSpPr txBox="1"/>
           <p:nvPr/>
         </p:nvSpPr>
         <p:spPr>
           <a:xfrm>
-            <a:off x="6291072" y="1645920"/>
-            <a:ext cx="2231136" cy="4297680"/>
+            <a:off x="6291072" y="1554480"/>
+            <a:ext cx="2231136" cy="4572000"/>
           </a:xfrm>
           <a:prstGeom prst="rect">
             <a:avLst/>
@@ -7102,10 +6765,27 @@
                 <a:solidFill>
                   <a:srgbClr val="0F172A"/>
                 </a:solidFill>
-              </a:defRPr>
-            </a:pPr>
-            <a:r>
-              <a:t>Embedded (ESP32 Firmware)</a:t>
+                <a:latin typeface="Syne"/>
+              </a:defRPr>
+            </a:pPr>
+            <a:r>
+              <a:t>ESP32 Firmware</a:t>
+            </a:r>
+          </a:p>
+          <a:p>
+            <a:pPr>
+              <a:spcBef>
+                <a:spcPts val="200"/>
+              </a:spcBef>
+              <a:defRPr sz="900" b="1">
+                <a:solidFill>
+                  <a:srgbClr val="0284C7"/>
+                </a:solidFill>
+                <a:latin typeface="Space Mono"/>
+              </a:defRPr>
+            </a:pPr>
+            <a:r>
+              <a:t>EMBEDDED FIRMWARE</a:t>
             </a:r>
           </a:p>
           <a:p>
@@ -7113,14 +6793,15 @@
               <a:spcBef>
                 <a:spcPts val="800"/>
               </a:spcBef>
-              <a:defRPr sz="1050">
+              <a:defRPr sz="1000">
                 <a:solidFill>
                   <a:srgbClr val="475569"/>
                 </a:solidFill>
-              </a:defRPr>
-            </a:pPr>
-            <a:r>
-              <a:t>• FreeRTOS Dual-Core Task Scheduling</a:t>
+                <a:latin typeface="Outfit"/>
+              </a:defRPr>
+            </a:pPr>
+            <a:r>
+              <a:t>• FreeRTOS dual-core multitasking</a:t>
             </a:r>
           </a:p>
           <a:p>
@@ -7128,14 +6809,15 @@
               <a:spcBef>
                 <a:spcPts val="800"/>
               </a:spcBef>
-              <a:defRPr sz="1050">
+              <a:defRPr sz="1000">
                 <a:solidFill>
                   <a:srgbClr val="475569"/>
                 </a:solidFill>
-              </a:defRPr>
-            </a:pPr>
-            <a:r>
-              <a:t>• Hardware I2C Sensor Acquisition Bus</a:t>
+                <a:latin typeface="Outfit"/>
+              </a:defRPr>
+            </a:pPr>
+            <a:r>
+              <a:t>• Hardware I2C sensor bus acquisition</a:t>
             </a:r>
           </a:p>
           <a:p>
@@ -7143,14 +6825,15 @@
               <a:spcBef>
                 <a:spcPts val="800"/>
               </a:spcBef>
-              <a:defRPr sz="1050">
+              <a:defRPr sz="1000">
                 <a:solidFill>
                   <a:srgbClr val="475569"/>
                 </a:solidFill>
-              </a:defRPr>
-            </a:pPr>
-            <a:r>
-              <a:t>• PWM Actuator Control for Fans &amp; Peltier</a:t>
+                <a:latin typeface="Outfit"/>
+              </a:defRPr>
+            </a:pPr>
+            <a:r>
+              <a:t>• PWM control for cooling and damper</a:t>
             </a:r>
           </a:p>
           <a:p>
@@ -7158,14 +6841,15 @@
               <a:spcBef>
                 <a:spcPts val="800"/>
               </a:spcBef>
-              <a:defRPr sz="1050">
+              <a:defRPr sz="1000">
                 <a:solidFill>
                   <a:srgbClr val="475569"/>
                 </a:solidFill>
-              </a:defRPr>
-            </a:pPr>
-            <a:r>
-              <a:t>• Hardware Watchdog &amp; Network Self-Recovery</a:t>
+                <a:latin typeface="Outfit"/>
+              </a:defRPr>
+            </a:pPr>
+            <a:r>
+              <a:t>• Hardware watchdog self-recovery</a:t>
             </a:r>
           </a:p>
           <a:p>
@@ -7173,28 +6857,29 @@
               <a:spcBef>
                 <a:spcPts val="800"/>
               </a:spcBef>
-              <a:defRPr sz="1050">
+              <a:defRPr sz="1000">
                 <a:solidFill>
                   <a:srgbClr val="475569"/>
                 </a:solidFill>
-              </a:defRPr>
-            </a:pPr>
-            <a:r>
-              <a:t>• Cryptographic Nonce &amp; Signature Header</a:t>
-            </a:r>
-          </a:p>
-        </p:txBody>
-      </p:sp>
-      <p:sp>
-        <p:nvSpPr>
-          <p:cNvPr id="11" name="Rounded Rectangle 10"/>
+                <a:latin typeface="Outfit"/>
+              </a:defRPr>
+            </a:pPr>
+            <a:r>
+              <a:t>• Cryptographic nonce generator</a:t>
+            </a:r>
+          </a:p>
+        </p:txBody>
+      </p:sp>
+      <p:sp>
+        <p:nvSpPr>
+          <p:cNvPr id="12" name="Rounded Rectangle 11"/>
           <p:cNvSpPr/>
           <p:nvPr/>
         </p:nvSpPr>
         <p:spPr>
           <a:xfrm>
-            <a:off x="8823960" y="1463040"/>
-            <a:ext cx="2560320" cy="4663440"/>
+            <a:off x="8823960" y="1371600"/>
+            <a:ext cx="2560320" cy="4937760"/>
           </a:xfrm>
           <a:prstGeom prst="roundRect">
             <a:avLst/>
@@ -7232,14 +6917,14 @@
       </p:sp>
       <p:sp>
         <p:nvSpPr>
-          <p:cNvPr id="12" name="TextBox 11"/>
+          <p:cNvPr id="13" name="TextBox 12"/>
           <p:cNvSpPr txBox="1"/>
           <p:nvPr/>
         </p:nvSpPr>
         <p:spPr>
           <a:xfrm>
-            <a:off x="8988552" y="1645920"/>
-            <a:ext cx="2231136" cy="4297680"/>
+            <a:off x="8988552" y="1554480"/>
+            <a:ext cx="2231136" cy="4572000"/>
           </a:xfrm>
           <a:prstGeom prst="rect">
             <a:avLst/>
@@ -7257,10 +6942,27 @@
                 <a:solidFill>
                   <a:srgbClr val="0F172A"/>
                 </a:solidFill>
-              </a:defRPr>
-            </a:pPr>
-            <a:r>
-              <a:t>Verification &amp; CI/CD</a:t>
+                <a:latin typeface="Syne"/>
+              </a:defRPr>
+            </a:pPr>
+            <a:r>
+              <a:t>Automated QA</a:t>
+            </a:r>
+          </a:p>
+          <a:p>
+            <a:pPr>
+              <a:spcBef>
+                <a:spcPts val="200"/>
+              </a:spcBef>
+              <a:defRPr sz="900" b="1">
+                <a:solidFill>
+                  <a:srgbClr val="0284C7"/>
+                </a:solidFill>
+                <a:latin typeface="Space Mono"/>
+              </a:defRPr>
+            </a:pPr>
+            <a:r>
+              <a:t>VERIFICATION &amp; CI/CD</a:t>
             </a:r>
           </a:p>
           <a:p>
@@ -7268,14 +6970,15 @@
               <a:spcBef>
                 <a:spcPts val="800"/>
               </a:spcBef>
-              <a:defRPr sz="1050">
+              <a:defRPr sz="1000">
                 <a:solidFill>
                   <a:srgbClr val="475569"/>
                 </a:solidFill>
-              </a:defRPr>
-            </a:pPr>
-            <a:r>
-              <a:t>• 144+ Automated Python Unit &amp; Integration Tests</a:t>
+                <a:latin typeface="Outfit"/>
+              </a:defRPr>
+            </a:pPr>
+            <a:r>
+              <a:t>• 144+ automated Python tests</a:t>
             </a:r>
           </a:p>
           <a:p>
@@ -7283,14 +6986,15 @@
               <a:spcBef>
                 <a:spcPts val="800"/>
               </a:spcBef>
-              <a:defRPr sz="1050">
+              <a:defRPr sz="1000">
                 <a:solidFill>
                   <a:srgbClr val="475569"/>
                 </a:solidFill>
-              </a:defRPr>
-            </a:pPr>
-            <a:r>
-              <a:t>• E2E Playwright Browser Test Suite</a:t>
+                <a:latin typeface="Outfit"/>
+              </a:defRPr>
+            </a:pPr>
+            <a:r>
+              <a:t>• Playwright E2E browser test suite</a:t>
             </a:r>
           </a:p>
           <a:p>
@@ -7298,14 +7002,15 @@
               <a:spcBef>
                 <a:spcPts val="800"/>
               </a:spcBef>
-              <a:defRPr sz="1050">
+              <a:defRPr sz="1000">
                 <a:solidFill>
                   <a:srgbClr val="475569"/>
                 </a:solidFill>
-              </a:defRPr>
-            </a:pPr>
-            <a:r>
-              <a:t>• Turbopack Zero-Error Build Guarantee</a:t>
+                <a:latin typeface="Outfit"/>
+              </a:defRPr>
+            </a:pPr>
+            <a:r>
+              <a:t>• Turbopack zero-error build guarantee</a:t>
             </a:r>
           </a:p>
           <a:p>
@@ -7313,14 +7018,15 @@
               <a:spcBef>
                 <a:spcPts val="800"/>
               </a:spcBef>
-              <a:defRPr sz="1050">
+              <a:defRPr sz="1000">
                 <a:solidFill>
                   <a:srgbClr val="475569"/>
                 </a:solidFill>
-              </a:defRPr>
-            </a:pPr>
-            <a:r>
-              <a:t>• Strict NPM Lockfile Resolution</a:t>
+                <a:latin typeface="Outfit"/>
+              </a:defRPr>
+            </a:pPr>
+            <a:r>
+              <a:t>• Strict NPM lockfile resolution</a:t>
             </a:r>
           </a:p>
           <a:p>
@@ -7328,14 +7034,15 @@
               <a:spcBef>
                 <a:spcPts val="800"/>
               </a:spcBef>
-              <a:defRPr sz="1050">
+              <a:defRPr sz="1000">
                 <a:solidFill>
                   <a:srgbClr val="475569"/>
                 </a:solidFill>
-              </a:defRPr>
-            </a:pPr>
-            <a:r>
-              <a:t>• Production Vercel Pipeline Continuous Deploy</a:t>
+                <a:latin typeface="Outfit"/>
+              </a:defRPr>
+            </a:pPr>
+            <a:r>
+              <a:t>• Continuous automated GitHub deploy</a:t>
             </a:r>
           </a:p>
         </p:txBody>
@@ -7410,7 +7117,7 @@
         <p:spPr>
           <a:xfrm>
             <a:off x="731520" y="365760"/>
-            <a:ext cx="10515600" cy="320040"/>
+            <a:ext cx="9144000" cy="320040"/>
           </a:xfrm>
           <a:prstGeom prst="rect">
             <a:avLst/>
@@ -7424,14 +7131,15 @@
           <a:lstStyle/>
           <a:p>
             <a:pPr>
-              <a:defRPr sz="1000" b="1">
+              <a:defRPr sz="950" b="1">
                 <a:solidFill>
                   <a:srgbClr val="0284C7"/>
                 </a:solidFill>
-              </a:defRPr>
-            </a:pPr>
-            <a:r>
-              <a:t>ROADMAP &amp; CONCLUSION</a:t>
+                <a:latin typeface="Space Mono"/>
+              </a:defRPr>
+            </a:pPr>
+            <a:r>
+              <a:t>LOOKING FORWARD</a:t>
             </a:r>
           </a:p>
         </p:txBody>
@@ -7444,8 +7152,8 @@
         </p:nvSpPr>
         <p:spPr>
           <a:xfrm>
-            <a:off x="731520" y="685800"/>
-            <a:ext cx="10515600" cy="594360"/>
+            <a:off x="731520" y="658368"/>
+            <a:ext cx="9601200" cy="594360"/>
           </a:xfrm>
           <a:prstGeom prst="rect">
             <a:avLst/>
@@ -7459,28 +7167,65 @@
           <a:lstStyle/>
           <a:p>
             <a:pPr>
-              <a:defRPr sz="2600" b="1">
+              <a:defRPr sz="2500" b="1">
                 <a:solidFill>
                   <a:srgbClr val="0F172A"/>
                 </a:solidFill>
-              </a:defRPr>
-            </a:pPr>
-            <a:r>
-              <a:t>Future Innovations &amp; Deployment Summary</a:t>
-            </a:r>
-          </a:p>
-        </p:txBody>
-      </p:sp>
-      <p:sp>
-        <p:nvSpPr>
-          <p:cNvPr id="5" name="Rounded Rectangle 4"/>
+                <a:latin typeface="Syne"/>
+              </a:defRPr>
+            </a:pPr>
+            <a:r>
+              <a:t>Strategic Roadmap &amp; Future Innovations</a:t>
+            </a:r>
+          </a:p>
+        </p:txBody>
+      </p:sp>
+      <p:sp>
+        <p:nvSpPr>
+          <p:cNvPr id="5" name="TextBox 4"/>
+          <p:cNvSpPr txBox="1"/>
+          <p:nvPr/>
+        </p:nvSpPr>
+        <p:spPr>
+          <a:xfrm>
+            <a:off x="10515600" y="365760"/>
+            <a:ext cx="1097280" cy="365760"/>
+          </a:xfrm>
+          <a:prstGeom prst="rect">
+            <a:avLst/>
+          </a:prstGeom>
+          <a:noFill/>
+        </p:spPr>
+        <p:txBody>
+          <a:bodyPr wrap="none">
+            <a:spAutoFit/>
+          </a:bodyPr>
+          <a:lstStyle/>
+          <a:p>
+            <a:pPr>
+              <a:defRPr sz="1100">
+                <a:solidFill>
+                  <a:srgbClr val="475569"/>
+                </a:solidFill>
+                <a:latin typeface="Space Mono"/>
+              </a:defRPr>
+            </a:pPr>
+            <a:r>
+              <a:t>09 / 09</a:t>
+            </a:r>
+          </a:p>
+        </p:txBody>
+      </p:sp>
+      <p:sp>
+        <p:nvSpPr>
+          <p:cNvPr id="6" name="Rounded Rectangle 5"/>
           <p:cNvSpPr/>
           <p:nvPr/>
         </p:nvSpPr>
         <p:spPr>
           <a:xfrm>
-            <a:off x="731520" y="1463040"/>
-            <a:ext cx="3383280" cy="4663440"/>
+            <a:off x="731520" y="1371600"/>
+            <a:ext cx="3383280" cy="4937760"/>
           </a:xfrm>
           <a:prstGeom prst="roundRect">
             <a:avLst/>
@@ -7518,13 +7263,13 @@
       </p:sp>
       <p:sp>
         <p:nvSpPr>
-          <p:cNvPr id="6" name="Rectangle 5"/>
+          <p:cNvPr id="7" name="Rectangle 6"/>
           <p:cNvSpPr/>
           <p:nvPr/>
         </p:nvSpPr>
         <p:spPr>
           <a:xfrm>
-            <a:off x="914400" y="1645920"/>
+            <a:off x="914400" y="1554480"/>
             <a:ext cx="3017520" cy="54864"/>
           </a:xfrm>
           <a:prstGeom prst="rect">
@@ -7561,14 +7306,14 @@
       </p:sp>
       <p:sp>
         <p:nvSpPr>
-          <p:cNvPr id="7" name="TextBox 6"/>
+          <p:cNvPr id="8" name="TextBox 7"/>
           <p:cNvSpPr txBox="1"/>
           <p:nvPr/>
         </p:nvSpPr>
         <p:spPr>
           <a:xfrm>
-            <a:off x="914400" y="1828800"/>
-            <a:ext cx="3017520" cy="4114800"/>
+            <a:off x="914400" y="1737360"/>
+            <a:ext cx="3017520" cy="4389120"/>
           </a:xfrm>
           <a:prstGeom prst="rect">
             <a:avLst/>
@@ -7582,14 +7327,31 @@
           <a:lstStyle/>
           <a:p>
             <a:pPr>
-              <a:defRPr sz="1500" b="1">
+              <a:defRPr sz="1400" b="1">
                 <a:solidFill>
                   <a:srgbClr val="0F172A"/>
                 </a:solidFill>
+                <a:latin typeface="Syne"/>
               </a:defRPr>
             </a:pPr>
             <a:r>
               <a:t>Phase 1: Present (Completed)</a:t>
+            </a:r>
+          </a:p>
+          <a:p>
+            <a:pPr>
+              <a:spcBef>
+                <a:spcPts val="300"/>
+              </a:spcBef>
+              <a:defRPr sz="950" b="1">
+                <a:solidFill>
+                  <a:srgbClr val="10B981"/>
+                </a:solidFill>
+                <a:latin typeface="Space Mono"/>
+              </a:defRPr>
+            </a:pPr>
+            <a:r>
+              <a:t>CURRENT PRODUCTION</a:t>
             </a:r>
           </a:p>
           <a:p>
@@ -7597,10 +7359,11 @@
               <a:spcBef>
                 <a:spcPts val="1000"/>
               </a:spcBef>
-              <a:defRPr sz="1100">
+              <a:defRPr sz="1050">
                 <a:solidFill>
                   <a:srgbClr val="475569"/>
                 </a:solidFill>
+                <a:latin typeface="Outfit"/>
               </a:defRPr>
             </a:pPr>
             <a:r>
@@ -7612,10 +7375,11 @@
               <a:spcBef>
                 <a:spcPts val="1000"/>
               </a:spcBef>
-              <a:defRPr sz="1100">
+              <a:defRPr sz="1050">
                 <a:solidFill>
                   <a:srgbClr val="475569"/>
                 </a:solidFill>
+                <a:latin typeface="Outfit"/>
               </a:defRPr>
             </a:pPr>
             <a:r>
@@ -7627,10 +7391,11 @@
               <a:spcBef>
                 <a:spcPts val="1000"/>
               </a:spcBef>
-              <a:defRPr sz="1100">
+              <a:defRPr sz="1050">
                 <a:solidFill>
                   <a:srgbClr val="475569"/>
                 </a:solidFill>
+                <a:latin typeface="Outfit"/>
               </a:defRPr>
             </a:pPr>
             <a:r>
@@ -7642,10 +7407,11 @@
               <a:spcBef>
                 <a:spcPts val="1000"/>
               </a:spcBef>
-              <a:defRPr sz="1100">
+              <a:defRPr sz="1050">
                 <a:solidFill>
                   <a:srgbClr val="475569"/>
                 </a:solidFill>
+                <a:latin typeface="Outfit"/>
               </a:defRPr>
             </a:pPr>
             <a:r>
@@ -7656,14 +7422,14 @@
       </p:sp>
       <p:sp>
         <p:nvSpPr>
-          <p:cNvPr id="8" name="Rounded Rectangle 7"/>
+          <p:cNvPr id="9" name="Rounded Rectangle 8"/>
           <p:cNvSpPr/>
           <p:nvPr/>
         </p:nvSpPr>
         <p:spPr>
           <a:xfrm>
-            <a:off x="4297680" y="1463040"/>
-            <a:ext cx="3383280" cy="4663440"/>
+            <a:off x="4297680" y="1371600"/>
+            <a:ext cx="3383280" cy="4937760"/>
           </a:xfrm>
           <a:prstGeom prst="roundRect">
             <a:avLst/>
@@ -7701,13 +7467,13 @@
       </p:sp>
       <p:sp>
         <p:nvSpPr>
-          <p:cNvPr id="9" name="Rectangle 8"/>
+          <p:cNvPr id="10" name="Rectangle 9"/>
           <p:cNvSpPr/>
           <p:nvPr/>
         </p:nvSpPr>
         <p:spPr>
           <a:xfrm>
-            <a:off x="4480560" y="1645920"/>
+            <a:off x="4480560" y="1554480"/>
             <a:ext cx="3017520" cy="54864"/>
           </a:xfrm>
           <a:prstGeom prst="rect">
@@ -7744,14 +7510,14 @@
       </p:sp>
       <p:sp>
         <p:nvSpPr>
-          <p:cNvPr id="10" name="TextBox 9"/>
+          <p:cNvPr id="11" name="TextBox 10"/>
           <p:cNvSpPr txBox="1"/>
           <p:nvPr/>
         </p:nvSpPr>
         <p:spPr>
           <a:xfrm>
-            <a:off x="4480560" y="1828800"/>
-            <a:ext cx="3017520" cy="4114800"/>
+            <a:off x="4480560" y="1737360"/>
+            <a:ext cx="3017520" cy="4389120"/>
           </a:xfrm>
           <a:prstGeom prst="rect">
             <a:avLst/>
@@ -7765,14 +7531,31 @@
           <a:lstStyle/>
           <a:p>
             <a:pPr>
-              <a:defRPr sz="1500" b="1">
+              <a:defRPr sz="1400" b="1">
                 <a:solidFill>
                   <a:srgbClr val="0F172A"/>
                 </a:solidFill>
-              </a:defRPr>
-            </a:pPr>
-            <a:r>
-              <a:t>Phase 2: Automated Pick-and-Place</a:t>
+                <a:latin typeface="Syne"/>
+              </a:defRPr>
+            </a:pPr>
+            <a:r>
+              <a:t>Phase 2: Robotic Pick-and-Place</a:t>
+            </a:r>
+          </a:p>
+          <a:p>
+            <a:pPr>
+              <a:spcBef>
+                <a:spcPts val="300"/>
+              </a:spcBef>
+              <a:defRPr sz="950" b="1">
+                <a:solidFill>
+                  <a:srgbClr val="0284C7"/>
+                </a:solidFill>
+                <a:latin typeface="Space Mono"/>
+              </a:defRPr>
+            </a:pPr>
+            <a:r>
+              <a:t>Q3 2026 TARGET</a:t>
             </a:r>
           </a:p>
           <a:p>
@@ -7780,14 +7563,15 @@
               <a:spcBef>
                 <a:spcPts val="1000"/>
               </a:spcBef>
-              <a:defRPr sz="1100">
+              <a:defRPr sz="1050">
                 <a:solidFill>
                   <a:srgbClr val="475569"/>
                 </a:solidFill>
-              </a:defRPr>
-            </a:pPr>
-            <a:r>
-              <a:t>• Robotic gantry integration with CoreXY Cartesian rail.</a:t>
+                <a:latin typeface="Outfit"/>
+              </a:defRPr>
+            </a:pPr>
+            <a:r>
+              <a:t>• CoreXY Cartesian robotic gantry pick-and-place.</a:t>
             </a:r>
           </a:p>
           <a:p>
@@ -7795,14 +7579,15 @@
               <a:spcBef>
                 <a:spcPts val="1000"/>
               </a:spcBef>
-              <a:defRPr sz="1100">
+              <a:defRPr sz="1050">
                 <a:solidFill>
                   <a:srgbClr val="475569"/>
                 </a:solidFill>
-              </a:defRPr>
-            </a:pPr>
-            <a:r>
-              <a:t>• Automated drawer ejection and component bin extraction.</a:t>
+                <a:latin typeface="Outfit"/>
+              </a:defRPr>
+            </a:pPr>
+            <a:r>
+              <a:t>• Motorized automated drawer ejection &amp; bin presentation.</a:t>
             </a:r>
           </a:p>
           <a:p>
@@ -7810,14 +7595,15 @@
               <a:spcBef>
                 <a:spcPts val="1000"/>
               </a:spcBef>
-              <a:defRPr sz="1100">
+              <a:defRPr sz="1050">
                 <a:solidFill>
                   <a:srgbClr val="475569"/>
                 </a:solidFill>
-              </a:defRPr>
-            </a:pPr>
-            <a:r>
-              <a:t>• Barcode / QR-code optical scan verification on intake.</a:t>
+                <a:latin typeface="Outfit"/>
+              </a:defRPr>
+            </a:pPr>
+            <a:r>
+              <a:t>• Optical QR/Barcode intake scan verification.</a:t>
             </a:r>
           </a:p>
           <a:p>
@@ -7825,28 +7611,29 @@
               <a:spcBef>
                 <a:spcPts val="1000"/>
               </a:spcBef>
-              <a:defRPr sz="1100">
+              <a:defRPr sz="1050">
                 <a:solidFill>
                   <a:srgbClr val="475569"/>
                 </a:solidFill>
-              </a:defRPr>
-            </a:pPr>
-            <a:r>
-              <a:t>• Multi-cabinet master/replica clustering.</a:t>
-            </a:r>
-          </a:p>
-        </p:txBody>
-      </p:sp>
-      <p:sp>
-        <p:nvSpPr>
-          <p:cNvPr id="11" name="Rounded Rectangle 10"/>
+                <a:latin typeface="Outfit"/>
+              </a:defRPr>
+            </a:pPr>
+            <a:r>
+              <a:t>• Master-replica multi-cabinet mesh network.</a:t>
+            </a:r>
+          </a:p>
+        </p:txBody>
+      </p:sp>
+      <p:sp>
+        <p:nvSpPr>
+          <p:cNvPr id="12" name="Rounded Rectangle 11"/>
           <p:cNvSpPr/>
           <p:nvPr/>
         </p:nvSpPr>
         <p:spPr>
           <a:xfrm>
-            <a:off x="7863840" y="1463040"/>
-            <a:ext cx="3383280" cy="4663440"/>
+            <a:off x="7863840" y="1371600"/>
+            <a:ext cx="3383280" cy="4937760"/>
           </a:xfrm>
           <a:prstGeom prst="roundRect">
             <a:avLst/>
@@ -7884,13 +7671,13 @@
       </p:sp>
       <p:sp>
         <p:nvSpPr>
-          <p:cNvPr id="12" name="Rectangle 11"/>
+          <p:cNvPr id="13" name="Rectangle 12"/>
           <p:cNvSpPr/>
           <p:nvPr/>
         </p:nvSpPr>
         <p:spPr>
           <a:xfrm>
-            <a:off x="8046720" y="1645920"/>
+            <a:off x="8046720" y="1554480"/>
             <a:ext cx="3017520" cy="54864"/>
           </a:xfrm>
           <a:prstGeom prst="rect">
@@ -7927,14 +7714,14 @@
       </p:sp>
       <p:sp>
         <p:nvSpPr>
-          <p:cNvPr id="13" name="TextBox 12"/>
+          <p:cNvPr id="14" name="TextBox 13"/>
           <p:cNvSpPr txBox="1"/>
           <p:nvPr/>
         </p:nvSpPr>
         <p:spPr>
           <a:xfrm>
-            <a:off x="8046720" y="1828800"/>
-            <a:ext cx="3017520" cy="4114800"/>
+            <a:off x="8046720" y="1737360"/>
+            <a:ext cx="3017520" cy="4389120"/>
           </a:xfrm>
           <a:prstGeom prst="rect">
             <a:avLst/>
@@ -7948,14 +7735,31 @@
           <a:lstStyle/>
           <a:p>
             <a:pPr>
-              <a:defRPr sz="1500" b="1">
+              <a:defRPr sz="1400" b="1">
                 <a:solidFill>
                   <a:srgbClr val="0F172A"/>
                 </a:solidFill>
+                <a:latin typeface="Syne"/>
               </a:defRPr>
             </a:pPr>
             <a:r>
               <a:t>Phase 3: Autonomous Factory AI</a:t>
+            </a:r>
+          </a:p>
+          <a:p>
+            <a:pPr>
+              <a:spcBef>
+                <a:spcPts val="300"/>
+              </a:spcBef>
+              <a:defRPr sz="950" b="1">
+                <a:solidFill>
+                  <a:srgbClr val="F59E0B"/>
+                </a:solidFill>
+                <a:latin typeface="Space Mono"/>
+              </a:defRPr>
+            </a:pPr>
+            <a:r>
+              <a:t>Q1 2027 SCALE</a:t>
             </a:r>
           </a:p>
           <a:p>
@@ -7963,14 +7767,15 @@
               <a:spcBef>
                 <a:spcPts val="1000"/>
               </a:spcBef>
-              <a:defRPr sz="1100">
+              <a:defRPr sz="1050">
                 <a:solidFill>
                   <a:srgbClr val="475569"/>
                 </a:solidFill>
-              </a:defRPr>
-            </a:pPr>
-            <a:r>
-              <a:t>• Predictive thermal modeling via deep reinforcement learning.</a:t>
+                <a:latin typeface="Outfit"/>
+              </a:defRPr>
+            </a:pPr>
+            <a:r>
+              <a:t>• Deep reinforcement learning predictive climate optimization.</a:t>
             </a:r>
           </a:p>
           <a:p>
@@ -7978,14 +7783,15 @@
               <a:spcBef>
                 <a:spcPts val="1000"/>
               </a:spcBef>
-              <a:defRPr sz="1100">
+              <a:defRPr sz="1050">
                 <a:solidFill>
                   <a:srgbClr val="475569"/>
                 </a:solidFill>
-              </a:defRPr>
-            </a:pPr>
-            <a:r>
-              <a:t>• Direct ERP integration (SAP, Oracle SCM, NetSuite).</a:t>
+                <a:latin typeface="Outfit"/>
+              </a:defRPr>
+            </a:pPr>
+            <a:r>
+              <a:t>• Direct enterprise ERP integration (SAP, Oracle SCM).</a:t>
             </a:r>
           </a:p>
           <a:p>
@@ -7993,14 +7799,15 @@
               <a:spcBef>
                 <a:spcPts val="1000"/>
               </a:spcBef>
-              <a:defRPr sz="1100">
+              <a:defRPr sz="1050">
                 <a:solidFill>
                   <a:srgbClr val="475569"/>
                 </a:solidFill>
-              </a:defRPr>
-            </a:pPr>
-            <a:r>
-              <a:t>• Enterprise Multi-Tenant Role-Based Access Control.</a:t>
+                <a:latin typeface="Outfit"/>
+              </a:defRPr>
+            </a:pPr>
+            <a:r>
+              <a:t>• Multi-tenant role-based access control (RBAC).</a:t>
             </a:r>
           </a:p>
           <a:p>
@@ -8008,14 +7815,15 @@
               <a:spcBef>
                 <a:spcPts val="1000"/>
               </a:spcBef>
-              <a:defRPr sz="1100">
+              <a:defRPr sz="1050">
                 <a:solidFill>
                   <a:srgbClr val="475569"/>
                 </a:solidFill>
-              </a:defRPr>
-            </a:pPr>
-            <a:r>
-              <a:t>• Field telemetry telemetry federation across global facilities.</a:t>
+                <a:latin typeface="Outfit"/>
+              </a:defRPr>
+            </a:pPr>
+            <a:r>
+              <a:t>• Global fab telemetry federation across distributed facilities.</a:t>
             </a:r>
           </a:p>
         </p:txBody>

</xml_diff>